<commit_message>
docs: present completed AlfaGen workflow in six slides
</commit_message>
<xml_diff>
--- a/presentation/alfagen-pii/deck.pptx
+++ b/presentation/alfagen-pii/deck.pptx
@@ -2,19 +2,18 @@
 <file path=ppt/presentation.xml><?xml version="1.0" encoding="utf-8"?>
 <p:presentation xmlns:p="http://schemas.openxmlformats.org/presentationml/2006/main">
   <p:sldMasterIdLst>
-    <p:sldMasterId xmlns:r="http://schemas.openxmlformats.org/officeDocument/2006/relationships" id="2147483648" r:id="R6ae4070e43454b47"/>
+    <p:sldMasterId xmlns:r="http://schemas.openxmlformats.org/officeDocument/2006/relationships" id="2147483648" r:id="R12398a083a214980"/>
   </p:sldMasterIdLst>
   <p:notesMasterIdLst>
-    <p:notesMasterId xmlns:r="http://schemas.openxmlformats.org/officeDocument/2006/relationships" r:id="Rf589d19103c44ebb"/>
+    <p:notesMasterId xmlns:r="http://schemas.openxmlformats.org/officeDocument/2006/relationships" r:id="Rb24883d75b4148bd"/>
   </p:notesMasterIdLst>
   <p:sldIdLst>
-    <p:sldId xmlns:r="http://schemas.openxmlformats.org/officeDocument/2006/relationships" id="256" r:id="R935442f0597f4d25"/>
-    <p:sldId xmlns:r="http://schemas.openxmlformats.org/officeDocument/2006/relationships" id="257" r:id="Rfba40d1869ae4509"/>
-    <p:sldId xmlns:r="http://schemas.openxmlformats.org/officeDocument/2006/relationships" id="258" r:id="R3a9de950210146d9"/>
-    <p:sldId xmlns:r="http://schemas.openxmlformats.org/officeDocument/2006/relationships" id="259" r:id="Rc04bf210499e41d0"/>
-    <p:sldId xmlns:r="http://schemas.openxmlformats.org/officeDocument/2006/relationships" id="260" r:id="R9ba457fb806f4781"/>
-    <p:sldId xmlns:r="http://schemas.openxmlformats.org/officeDocument/2006/relationships" id="261" r:id="R9f10e747a0d343fc"/>
-    <p:sldId xmlns:r="http://schemas.openxmlformats.org/officeDocument/2006/relationships" id="262" r:id="R14b08f6ed8bf4920"/>
+    <p:sldId xmlns:r="http://schemas.openxmlformats.org/officeDocument/2006/relationships" id="256" r:id="Rd4ef89135a6e4716"/>
+    <p:sldId xmlns:r="http://schemas.openxmlformats.org/officeDocument/2006/relationships" id="257" r:id="R419c9cadf1ec44ab"/>
+    <p:sldId xmlns:r="http://schemas.openxmlformats.org/officeDocument/2006/relationships" id="258" r:id="Rf8c99ee66c494138"/>
+    <p:sldId xmlns:r="http://schemas.openxmlformats.org/officeDocument/2006/relationships" id="259" r:id="R0d4b0c9b4c8b43af"/>
+    <p:sldId xmlns:r="http://schemas.openxmlformats.org/officeDocument/2006/relationships" id="260" r:id="R27107dc2edab4a4e"/>
+    <p:sldId xmlns:r="http://schemas.openxmlformats.org/officeDocument/2006/relationships" id="261" r:id="Ra544f8e3245444c2"/>
   </p:sldIdLst>
   <p:sldSz cx="9144000" cy="5143500"/>
   <p:notesSz cx="6858000" cy="9144000"/>
@@ -804,72 +803,6 @@
 </p:notes>
 </file>
 
-<file path=ppt/notesSlides/notesSlide7.xml><?xml version="1.0" encoding="utf-8"?>
-<p:notes xmlns:p="http://schemas.openxmlformats.org/presentationml/2006/main">
-  <p:cSld>
-    <p:spTree>
-      <p:nvGrpSpPr>
-        <p:cNvPr id="1" name=""/>
-        <p:cNvGrpSpPr/>
-        <p:nvPr/>
-      </p:nvGrpSpPr>
-      <p:grpSpPr>
-        <a:xfrm xmlns:a="http://schemas.openxmlformats.org/drawingml/2006/main"/>
-      </p:grpSpPr>
-      <p:sp>
-        <p:nvSpPr>
-          <p:cNvPr id="2" name="Slide Image Placeholder 1"/>
-          <p:cNvSpPr>
-            <a:spLocks xmlns:a="http://schemas.openxmlformats.org/drawingml/2006/main" noGrp="1"/>
-          </p:cNvSpPr>
-          <p:nvPr>
-            <p:ph type="sldImg" idx="0"/>
-          </p:nvPr>
-        </p:nvSpPr>
-        <p:spPr/>
-      </p:sp>
-      <p:sp>
-        <p:nvSpPr>
-          <p:cNvPr id="3" name="Notes Placeholder 2"/>
-          <p:cNvSpPr>
-            <a:spLocks xmlns:a="http://schemas.openxmlformats.org/drawingml/2006/main" noGrp="1"/>
-          </p:cNvSpPr>
-          <p:nvPr>
-            <p:ph type="body" idx="1"/>
-          </p:nvPr>
-        </p:nvSpPr>
-        <p:spPr/>
-        <p:txBody>
-          <a:bodyPr xmlns:a="http://schemas.openxmlformats.org/drawingml/2006/main"/>
-          <a:lstStyle xmlns:a="http://schemas.openxmlformats.org/drawingml/2006/main"/>
-          <a:p xmlns:a="http://schemas.openxmlformats.org/drawingml/2006/main"/>
-        </p:txBody>
-      </p:sp>
-      <p:sp>
-        <p:nvSpPr>
-          <p:cNvPr id="4" name="Slide Number Placeholder 3"/>
-          <p:cNvSpPr>
-            <a:spLocks xmlns:a="http://schemas.openxmlformats.org/drawingml/2006/main" noGrp="1"/>
-          </p:cNvSpPr>
-          <p:nvPr>
-            <p:ph type="sldNum" idx="5"/>
-          </p:nvPr>
-        </p:nvSpPr>
-        <p:spPr/>
-        <p:txBody>
-          <a:bodyPr xmlns:a="http://schemas.openxmlformats.org/drawingml/2006/main"/>
-          <a:lstStyle xmlns:a="http://schemas.openxmlformats.org/drawingml/2006/main"/>
-          <a:p xmlns:a="http://schemas.openxmlformats.org/drawingml/2006/main"/>
-        </p:txBody>
-      </p:sp>
-    </p:spTree>
-  </p:cSld>
-  <p:clrMapOvr>
-    <a:masterClrMapping xmlns:a="http://schemas.openxmlformats.org/drawingml/2006/main"/>
-  </p:clrMapOvr>
-</p:notes>
-</file>
-
 <file path=ppt/slideLayouts/slideLayout1.xml><?xml version="1.0" encoding="utf-8"?>
 <p:sldLayout xmlns:p="http://schemas.openxmlformats.org/presentationml/2006/main" type="title">
   <p:cSld name="Title Slide">
@@ -908,7 +841,7 @@
   </p:cSld>
   <p:clrMap bg1="lt1" tx1="dk1" bg2="lt2" tx2="dk2" accent1="accent1" accent2="accent2" accent3="accent3" accent4="accent4" accent5="accent5" accent6="accent6" hlink="hlink" folHlink="folHlink"/>
   <p:sldLayoutIdLst>
-    <p:sldLayoutId xmlns:r="http://schemas.openxmlformats.org/officeDocument/2006/relationships" id="2147483649" r:id="R8762b02604e84a09"/>
+    <p:sldLayoutId xmlns:r="http://schemas.openxmlformats.org/officeDocument/2006/relationships" id="2147483649" r:id="R67f0746b89944852"/>
   </p:sldLayoutIdLst>
   <p:txStyles>
     <p:titleStyle>
@@ -1459,7 +1392,7 @@
           <p:cNvPr id="9" name="eyebrow">
             <a:extLst xmlns:a="http://schemas.openxmlformats.org/drawingml/2006/main">
               <a:ext uri="{FF2B5EF4-FFF2-40B4-BE49-F238E27FC236}">
-                <a16:creationId xmlns:a16="http://schemas.microsoft.com/office/drawing/2014/main" id="{EB791947-87FD-4841-ACB9-72ABD570F00F}"/>
+                <a16:creationId xmlns:a16="http://schemas.microsoft.com/office/drawing/2014/main" id="{F63A81F2-5ED2-47A6-B890-878A2E567529}"/>
               </a:ext>
             </a:extLst>
           </p:cNvPr>
@@ -1517,7 +1450,7 @@
           <p:cNvPr id="2" name="top-rule">
             <a:extLst xmlns:a="http://schemas.openxmlformats.org/drawingml/2006/main">
               <a:ext uri="{FF2B5EF4-FFF2-40B4-BE49-F238E27FC236}">
-                <a16:creationId xmlns:a16="http://schemas.microsoft.com/office/drawing/2014/main" id="{B4ED5CA7-5185-4835-B502-610ABFC96A75}"/>
+                <a16:creationId xmlns:a16="http://schemas.microsoft.com/office/drawing/2014/main" id="{5018D04C-1B6A-4A92-A392-95819E19BE56}"/>
               </a:ext>
             </a:extLst>
           </p:cNvPr>
@@ -1548,7 +1481,7 @@
           <p:cNvPr id="3" name="red-index">
             <a:extLst xmlns:a="http://schemas.openxmlformats.org/drawingml/2006/main">
               <a:ext uri="{FF2B5EF4-FFF2-40B4-BE49-F238E27FC236}">
-                <a16:creationId xmlns:a16="http://schemas.microsoft.com/office/drawing/2014/main" id="{60DB5ED6-8CA5-41F2-A577-58DDFC1D0818}"/>
+                <a16:creationId xmlns:a16="http://schemas.microsoft.com/office/drawing/2014/main" id="{F09E2F1E-70F7-4F2A-80D5-34F0904C7849}"/>
               </a:ext>
             </a:extLst>
           </p:cNvPr>
@@ -1606,7 +1539,7 @@
           <p:cNvPr id="4" name="title">
             <a:extLst xmlns:a="http://schemas.openxmlformats.org/drawingml/2006/main">
               <a:ext uri="{FF2B5EF4-FFF2-40B4-BE49-F238E27FC236}">
-                <a16:creationId xmlns:a16="http://schemas.microsoft.com/office/drawing/2014/main" id="{D025C16D-17FB-4A14-89DC-B296072F2F04}"/>
+                <a16:creationId xmlns:a16="http://schemas.microsoft.com/office/drawing/2014/main" id="{08A03A6D-D52A-41B7-9596-9B8EE6D20965}"/>
               </a:ext>
             </a:extLst>
           </p:cNvPr>
@@ -1692,7 +1625,7 @@
           <p:cNvPr id="5" name="subtitle">
             <a:extLst xmlns:a="http://schemas.openxmlformats.org/drawingml/2006/main">
               <a:ext uri="{FF2B5EF4-FFF2-40B4-BE49-F238E27FC236}">
-                <a16:creationId xmlns:a16="http://schemas.microsoft.com/office/drawing/2014/main" id="{2B27DE10-416F-428C-92A5-4A2699AE21F4}"/>
+                <a16:creationId xmlns:a16="http://schemas.microsoft.com/office/drawing/2014/main" id="{D3D9FCAB-2FB7-4EC5-928F-0A2A33ABAAAB}"/>
               </a:ext>
             </a:extLst>
           </p:cNvPr>
@@ -1778,7 +1711,7 @@
           <p:cNvPr id="6" name="bottom-rule">
             <a:extLst xmlns:a="http://schemas.openxmlformats.org/drawingml/2006/main">
               <a:ext uri="{FF2B5EF4-FFF2-40B4-BE49-F238E27FC236}">
-                <a16:creationId xmlns:a16="http://schemas.microsoft.com/office/drawing/2014/main" id="{7CC38C2F-63E9-41CC-B646-CBBFC5AA99D5}"/>
+                <a16:creationId xmlns:a16="http://schemas.microsoft.com/office/drawing/2014/main" id="{8690D29B-50CF-42C5-B156-D2D5C89E4D0B}"/>
               </a:ext>
             </a:extLst>
           </p:cNvPr>
@@ -1809,7 +1742,7 @@
           <p:cNvPr id="7" name="footer">
             <a:extLst xmlns:a="http://schemas.openxmlformats.org/drawingml/2006/main">
               <a:ext uri="{FF2B5EF4-FFF2-40B4-BE49-F238E27FC236}">
-                <a16:creationId xmlns:a16="http://schemas.microsoft.com/office/drawing/2014/main" id="{CDD30EB3-0626-40BD-8037-7092908AD141}"/>
+                <a16:creationId xmlns:a16="http://schemas.microsoft.com/office/drawing/2014/main" id="{F7E969A1-8015-4C65-9209-191071F0EBAB}"/>
               </a:ext>
             </a:extLst>
           </p:cNvPr>
@@ -1867,7 +1800,7 @@
           <p:cNvPr id="8" name="page">
             <a:extLst xmlns:a="http://schemas.openxmlformats.org/drawingml/2006/main">
               <a:ext uri="{FF2B5EF4-FFF2-40B4-BE49-F238E27FC236}">
-                <a16:creationId xmlns:a16="http://schemas.microsoft.com/office/drawing/2014/main" id="{2C030F95-905B-49A7-B780-16BB3A6BFC33}"/>
+                <a16:creationId xmlns:a16="http://schemas.microsoft.com/office/drawing/2014/main" id="{94AA6387-5B59-44E4-9BAC-D183D1598B08}"/>
               </a:ext>
             </a:extLst>
           </p:cNvPr>
@@ -1915,7 +1848,7 @@
                 <a:ea typeface="Arial"/>
                 <a:cs typeface="Arial"/>
               </a:rPr>
-              <a:t>01 / 07</a:t>
+              <a:t>01 / 06</a:t>
             </a:r>
           </a:p>
         </p:txBody>
@@ -1923,7 +1856,7 @@
     </p:spTree>
     <p:extLst>
       <p:ext uri="{BB962C8B-B14F-4D97-AF65-F5344CB8AC3E}">
-        <p14:creationId xmlns:p14="http://schemas.microsoft.com/office/powerpoint/2010/main" val="382873232"/>
+        <p14:creationId xmlns:p14="http://schemas.microsoft.com/office/powerpoint/2010/main" val="1859323521"/>
       </p:ext>
     </p:extLst>
   </p:cSld>
@@ -1957,7 +1890,7 @@
           <p:cNvPr id="12" name="section">
             <a:extLst xmlns:a="http://schemas.openxmlformats.org/drawingml/2006/main">
               <a:ext uri="{FF2B5EF4-FFF2-40B4-BE49-F238E27FC236}">
-                <a16:creationId xmlns:a16="http://schemas.microsoft.com/office/drawing/2014/main" id="{7F6DDA44-11B7-4076-81DD-FACDA5B551DF}"/>
+                <a16:creationId xmlns:a16="http://schemas.microsoft.com/office/drawing/2014/main" id="{36600B3D-90AD-43EF-92A2-8100462B90CB}"/>
               </a:ext>
             </a:extLst>
           </p:cNvPr>
@@ -2015,7 +1948,7 @@
           <p:cNvPr id="2" name="title">
             <a:extLst xmlns:a="http://schemas.openxmlformats.org/drawingml/2006/main">
               <a:ext uri="{FF2B5EF4-FFF2-40B4-BE49-F238E27FC236}">
-                <a16:creationId xmlns:a16="http://schemas.microsoft.com/office/drawing/2014/main" id="{780F8137-9CD3-4D3E-9988-86567302449D}"/>
+                <a16:creationId xmlns:a16="http://schemas.microsoft.com/office/drawing/2014/main" id="{B8312910-0C80-4D81-8288-1699CE56FF97}"/>
               </a:ext>
             </a:extLst>
           </p:cNvPr>
@@ -2073,7 +2006,7 @@
           <p:cNvPr id="3" name="top-rule">
             <a:extLst xmlns:a="http://schemas.openxmlformats.org/drawingml/2006/main">
               <a:ext uri="{FF2B5EF4-FFF2-40B4-BE49-F238E27FC236}">
-                <a16:creationId xmlns:a16="http://schemas.microsoft.com/office/drawing/2014/main" id="{DDB219EA-9BFE-4B21-8A84-824CCFDC08EA}"/>
+                <a16:creationId xmlns:a16="http://schemas.microsoft.com/office/drawing/2014/main" id="{998B6BA0-537A-4BF8-AD4D-D19794BFB155}"/>
               </a:ext>
             </a:extLst>
           </p:cNvPr>
@@ -2104,7 +2037,7 @@
           <p:cNvPr id="4" name="big-17">
             <a:extLst xmlns:a="http://schemas.openxmlformats.org/drawingml/2006/main">
               <a:ext uri="{FF2B5EF4-FFF2-40B4-BE49-F238E27FC236}">
-                <a16:creationId xmlns:a16="http://schemas.microsoft.com/office/drawing/2014/main" id="{FAF6BFE5-2D35-4DA7-88F5-49545D82D46B}"/>
+                <a16:creationId xmlns:a16="http://schemas.microsoft.com/office/drawing/2014/main" id="{1A92F6F8-1DEE-4BDA-88FA-9DF80BA77874}"/>
               </a:ext>
             </a:extLst>
           </p:cNvPr>
@@ -2162,7 +2095,7 @@
           <p:cNvPr id="5" name="count-label">
             <a:extLst xmlns:a="http://schemas.openxmlformats.org/drawingml/2006/main">
               <a:ext uri="{FF2B5EF4-FFF2-40B4-BE49-F238E27FC236}">
-                <a16:creationId xmlns:a16="http://schemas.microsoft.com/office/drawing/2014/main" id="{B3D946D4-4952-47B1-866B-028D124D6571}"/>
+                <a16:creationId xmlns:a16="http://schemas.microsoft.com/office/drawing/2014/main" id="{1FF9EF02-1956-4684-9DD6-C98AC76C0C37}"/>
               </a:ext>
             </a:extLst>
           </p:cNvPr>
@@ -2243,7 +2176,7 @@
           <p:cNvPr id="6" name="vertical-rule">
             <a:extLst xmlns:a="http://schemas.openxmlformats.org/drawingml/2006/main">
               <a:ext uri="{FF2B5EF4-FFF2-40B4-BE49-F238E27FC236}">
-                <a16:creationId xmlns:a16="http://schemas.microsoft.com/office/drawing/2014/main" id="{CFB6140E-DAF9-475A-899C-5B4EF82DB1EE}"/>
+                <a16:creationId xmlns:a16="http://schemas.microsoft.com/office/drawing/2014/main" id="{3CFE24F2-E22E-4A1F-935E-4CA056688A98}"/>
               </a:ext>
             </a:extLst>
           </p:cNvPr>
@@ -2274,7 +2207,7 @@
           <p:cNvPr id="7" name="mechanism">
             <a:extLst xmlns:a="http://schemas.openxmlformats.org/drawingml/2006/main">
               <a:ext uri="{FF2B5EF4-FFF2-40B4-BE49-F238E27FC236}">
-                <a16:creationId xmlns:a16="http://schemas.microsoft.com/office/drawing/2014/main" id="{99A9B20F-A968-400D-894D-7D812E4FE932}"/>
+                <a16:creationId xmlns:a16="http://schemas.microsoft.com/office/drawing/2014/main" id="{1FBC006B-6D14-400E-B501-40C670D13857}"/>
               </a:ext>
             </a:extLst>
           </p:cNvPr>
@@ -2383,7 +2316,7 @@
           <p:cNvPr id="8" name="example-label">
             <a:extLst xmlns:a="http://schemas.openxmlformats.org/drawingml/2006/main">
               <a:ext uri="{FF2B5EF4-FFF2-40B4-BE49-F238E27FC236}">
-                <a16:creationId xmlns:a16="http://schemas.microsoft.com/office/drawing/2014/main" id="{DBC30A4C-6C03-4808-9909-8AC0A8CEA421}"/>
+                <a16:creationId xmlns:a16="http://schemas.microsoft.com/office/drawing/2014/main" id="{EAAB1109-00C4-4D80-A284-A6E1B8B264FB}"/>
               </a:ext>
             </a:extLst>
           </p:cNvPr>
@@ -2441,7 +2374,7 @@
           <p:cNvPr id="9" name="example-rule">
             <a:extLst xmlns:a="http://schemas.openxmlformats.org/drawingml/2006/main">
               <a:ext uri="{FF2B5EF4-FFF2-40B4-BE49-F238E27FC236}">
-                <a16:creationId xmlns:a16="http://schemas.microsoft.com/office/drawing/2014/main" id="{2231A3BE-F753-418D-A9B6-B1F3A336BA7A}"/>
+                <a16:creationId xmlns:a16="http://schemas.microsoft.com/office/drawing/2014/main" id="{4843D7B7-307C-4FB0-9E42-EECB6830018F}"/>
               </a:ext>
             </a:extLst>
           </p:cNvPr>
@@ -2472,7 +2405,7 @@
           <p:cNvPr id="10" name="example">
             <a:extLst xmlns:a="http://schemas.openxmlformats.org/drawingml/2006/main">
               <a:ext uri="{FF2B5EF4-FFF2-40B4-BE49-F238E27FC236}">
-                <a16:creationId xmlns:a16="http://schemas.microsoft.com/office/drawing/2014/main" id="{CEE15411-1B49-4A04-8E6C-F2C485E853F2}"/>
+                <a16:creationId xmlns:a16="http://schemas.microsoft.com/office/drawing/2014/main" id="{AE1E161C-2E58-4EDC-9E3B-99BB9734A003}"/>
               </a:ext>
             </a:extLst>
           </p:cNvPr>
@@ -2530,7 +2463,7 @@
           <p:cNvPr id="11" name="page">
             <a:extLst xmlns:a="http://schemas.openxmlformats.org/drawingml/2006/main">
               <a:ext uri="{FF2B5EF4-FFF2-40B4-BE49-F238E27FC236}">
-                <a16:creationId xmlns:a16="http://schemas.microsoft.com/office/drawing/2014/main" id="{A2C1D113-F8F3-4223-AAC0-6BFF100212A0}"/>
+                <a16:creationId xmlns:a16="http://schemas.microsoft.com/office/drawing/2014/main" id="{B2BAE0B2-7B92-41F9-8DE6-4795ADC46404}"/>
               </a:ext>
             </a:extLst>
           </p:cNvPr>
@@ -2578,7 +2511,7 @@
                 <a:ea typeface="Arial"/>
                 <a:cs typeface="Arial"/>
               </a:rPr>
-              <a:t>02 / 07</a:t>
+              <a:t>02 / 06</a:t>
             </a:r>
           </a:p>
         </p:txBody>
@@ -2586,7 +2519,7 @@
     </p:spTree>
     <p:extLst>
       <p:ext uri="{BB962C8B-B14F-4D97-AF65-F5344CB8AC3E}">
-        <p14:creationId xmlns:p14="http://schemas.microsoft.com/office/powerpoint/2010/main" val="1910203497"/>
+        <p14:creationId xmlns:p14="http://schemas.microsoft.com/office/powerpoint/2010/main" val="177893601"/>
       </p:ext>
     </p:extLst>
   </p:cSld>
@@ -2620,7 +2553,7 @@
           <p:cNvPr id="26" name="section">
             <a:extLst xmlns:a="http://schemas.openxmlformats.org/drawingml/2006/main">
               <a:ext uri="{FF2B5EF4-FFF2-40B4-BE49-F238E27FC236}">
-                <a16:creationId xmlns:a16="http://schemas.microsoft.com/office/drawing/2014/main" id="{6F17E045-3A47-490D-8A33-1DAA7AD22691}"/>
+                <a16:creationId xmlns:a16="http://schemas.microsoft.com/office/drawing/2014/main" id="{721DD68F-E247-4CED-8AAF-8E3F140C7799}"/>
               </a:ext>
             </a:extLst>
           </p:cNvPr>
@@ -2678,7 +2611,7 @@
           <p:cNvPr id="2" name="title">
             <a:extLst xmlns:a="http://schemas.openxmlformats.org/drawingml/2006/main">
               <a:ext uri="{FF2B5EF4-FFF2-40B4-BE49-F238E27FC236}">
-                <a16:creationId xmlns:a16="http://schemas.microsoft.com/office/drawing/2014/main" id="{53809CAE-D293-4CD2-9B2C-5D3E63EA1453}"/>
+                <a16:creationId xmlns:a16="http://schemas.microsoft.com/office/drawing/2014/main" id="{D28D2D83-E095-4E9E-B76C-A1EC24661B72}"/>
               </a:ext>
             </a:extLst>
           </p:cNvPr>
@@ -2736,7 +2669,7 @@
           <p:cNvPr id="3" name="top-rule">
             <a:extLst xmlns:a="http://schemas.openxmlformats.org/drawingml/2006/main">
               <a:ext uri="{FF2B5EF4-FFF2-40B4-BE49-F238E27FC236}">
-                <a16:creationId xmlns:a16="http://schemas.microsoft.com/office/drawing/2014/main" id="{21A951EB-2BC8-4FAE-9B1F-071FEE4E2384}"/>
+                <a16:creationId xmlns:a16="http://schemas.microsoft.com/office/drawing/2014/main" id="{07989A94-E6BD-4A44-BD7E-916AF8DFCAF9}"/>
               </a:ext>
             </a:extLst>
           </p:cNvPr>
@@ -2767,7 +2700,7 @@
           <p:cNvPr id="4" name="label-1">
             <a:extLst xmlns:a="http://schemas.openxmlformats.org/drawingml/2006/main">
               <a:ext uri="{FF2B5EF4-FFF2-40B4-BE49-F238E27FC236}">
-                <a16:creationId xmlns:a16="http://schemas.microsoft.com/office/drawing/2014/main" id="{759836E0-9012-4472-9C7F-51F34DB45847}"/>
+                <a16:creationId xmlns:a16="http://schemas.microsoft.com/office/drawing/2014/main" id="{B2F2C354-C350-4F08-BE3E-6A0FADABD2A9}"/>
               </a:ext>
             </a:extLst>
           </p:cNvPr>
@@ -2825,7 +2758,7 @@
           <p:cNvPr id="5" name="label-2">
             <a:extLst xmlns:a="http://schemas.openxmlformats.org/drawingml/2006/main">
               <a:ext uri="{FF2B5EF4-FFF2-40B4-BE49-F238E27FC236}">
-                <a16:creationId xmlns:a16="http://schemas.microsoft.com/office/drawing/2014/main" id="{2989F4D2-0F12-4FE5-B23D-E93F7540AEE6}"/>
+                <a16:creationId xmlns:a16="http://schemas.microsoft.com/office/drawing/2014/main" id="{9551DD35-F5BC-4AFF-9CF9-75E30D047362}"/>
               </a:ext>
             </a:extLst>
           </p:cNvPr>
@@ -2883,7 +2816,7 @@
           <p:cNvPr id="6" name="label-3">
             <a:extLst xmlns:a="http://schemas.openxmlformats.org/drawingml/2006/main">
               <a:ext uri="{FF2B5EF4-FFF2-40B4-BE49-F238E27FC236}">
-                <a16:creationId xmlns:a16="http://schemas.microsoft.com/office/drawing/2014/main" id="{4FBE0D14-8D25-4344-81EA-4577D2732F55}"/>
+                <a16:creationId xmlns:a16="http://schemas.microsoft.com/office/drawing/2014/main" id="{597C0033-ABF1-4019-9654-F82692301B52}"/>
               </a:ext>
             </a:extLst>
           </p:cNvPr>
@@ -2941,7 +2874,7 @@
           <p:cNvPr id="7" name="label-4">
             <a:extLst xmlns:a="http://schemas.openxmlformats.org/drawingml/2006/main">
               <a:ext uri="{FF2B5EF4-FFF2-40B4-BE49-F238E27FC236}">
-                <a16:creationId xmlns:a16="http://schemas.microsoft.com/office/drawing/2014/main" id="{DC97E2DE-424F-4CC0-9897-2362234457F6}"/>
+                <a16:creationId xmlns:a16="http://schemas.microsoft.com/office/drawing/2014/main" id="{EBD8F646-F040-4E5C-8817-4D4C5161B124}"/>
               </a:ext>
             </a:extLst>
           </p:cNvPr>
@@ -2999,7 +2932,7 @@
           <p:cNvPr id="8" name="label-5">
             <a:extLst xmlns:a="http://schemas.openxmlformats.org/drawingml/2006/main">
               <a:ext uri="{FF2B5EF4-FFF2-40B4-BE49-F238E27FC236}">
-                <a16:creationId xmlns:a16="http://schemas.microsoft.com/office/drawing/2014/main" id="{106218CE-98DD-4815-B046-D7067FF9C999}"/>
+                <a16:creationId xmlns:a16="http://schemas.microsoft.com/office/drawing/2014/main" id="{6C9A5CFA-E08F-482B-AFAB-C22A52117DC9}"/>
               </a:ext>
             </a:extLst>
           </p:cNvPr>
@@ -3057,7 +2990,7 @@
           <p:cNvPr id="9" name="flow-line">
             <a:extLst xmlns:a="http://schemas.openxmlformats.org/drawingml/2006/main">
               <a:ext uri="{FF2B5EF4-FFF2-40B4-BE49-F238E27FC236}">
-                <a16:creationId xmlns:a16="http://schemas.microsoft.com/office/drawing/2014/main" id="{7B6A986D-45DD-4974-9A06-39E4158332C1}"/>
+                <a16:creationId xmlns:a16="http://schemas.microsoft.com/office/drawing/2014/main" id="{DD390E97-A14F-4166-8E8D-01BDF459881F}"/>
               </a:ext>
             </a:extLst>
           </p:cNvPr>
@@ -3088,7 +3021,7 @@
           <p:cNvPr id="10" name="dot-1">
             <a:extLst xmlns:a="http://schemas.openxmlformats.org/drawingml/2006/main">
               <a:ext uri="{FF2B5EF4-FFF2-40B4-BE49-F238E27FC236}">
-                <a16:creationId xmlns:a16="http://schemas.microsoft.com/office/drawing/2014/main" id="{BA82C020-B7D2-4239-818E-67CB87C539AC}"/>
+                <a16:creationId xmlns:a16="http://schemas.microsoft.com/office/drawing/2014/main" id="{447360D2-4878-461B-8D36-8D5A5CEBE1DA}"/>
               </a:ext>
             </a:extLst>
           </p:cNvPr>
@@ -3119,7 +3052,7 @@
           <p:cNvPr id="11" name="dot-2">
             <a:extLst xmlns:a="http://schemas.openxmlformats.org/drawingml/2006/main">
               <a:ext uri="{FF2B5EF4-FFF2-40B4-BE49-F238E27FC236}">
-                <a16:creationId xmlns:a16="http://schemas.microsoft.com/office/drawing/2014/main" id="{5C4CB348-C127-4F32-A21E-019E92491FAB}"/>
+                <a16:creationId xmlns:a16="http://schemas.microsoft.com/office/drawing/2014/main" id="{386FB110-5AEB-4147-A0D5-7DA22741C5B4}"/>
               </a:ext>
             </a:extLst>
           </p:cNvPr>
@@ -3150,7 +3083,7 @@
           <p:cNvPr id="12" name="dot-3">
             <a:extLst xmlns:a="http://schemas.openxmlformats.org/drawingml/2006/main">
               <a:ext uri="{FF2B5EF4-FFF2-40B4-BE49-F238E27FC236}">
-                <a16:creationId xmlns:a16="http://schemas.microsoft.com/office/drawing/2014/main" id="{FF9788F2-C8B0-4CC0-8390-6ABE96E10829}"/>
+                <a16:creationId xmlns:a16="http://schemas.microsoft.com/office/drawing/2014/main" id="{93EBD3FE-C8AC-4C27-87A2-797D95E91F5D}"/>
               </a:ext>
             </a:extLst>
           </p:cNvPr>
@@ -3181,7 +3114,7 @@
           <p:cNvPr id="13" name="dot-4">
             <a:extLst xmlns:a="http://schemas.openxmlformats.org/drawingml/2006/main">
               <a:ext uri="{FF2B5EF4-FFF2-40B4-BE49-F238E27FC236}">
-                <a16:creationId xmlns:a16="http://schemas.microsoft.com/office/drawing/2014/main" id="{13B42855-5553-4B4F-8BB3-357179DC2D10}"/>
+                <a16:creationId xmlns:a16="http://schemas.microsoft.com/office/drawing/2014/main" id="{2676D168-BF79-4912-A001-DE8065736981}"/>
               </a:ext>
             </a:extLst>
           </p:cNvPr>
@@ -3212,7 +3145,7 @@
           <p:cNvPr id="14" name="dot-5">
             <a:extLst xmlns:a="http://schemas.openxmlformats.org/drawingml/2006/main">
               <a:ext uri="{FF2B5EF4-FFF2-40B4-BE49-F238E27FC236}">
-                <a16:creationId xmlns:a16="http://schemas.microsoft.com/office/drawing/2014/main" id="{2F0E54C3-7F9F-4192-9A7A-715DC1D22EC7}"/>
+                <a16:creationId xmlns:a16="http://schemas.microsoft.com/office/drawing/2014/main" id="{65D2CB8A-CB9C-4B8F-B137-F01BBCBF5089}"/>
               </a:ext>
             </a:extLst>
           </p:cNvPr>
@@ -3243,7 +3176,7 @@
           <p:cNvPr id="15" name="step-caption-1">
             <a:extLst xmlns:a="http://schemas.openxmlformats.org/drawingml/2006/main">
               <a:ext uri="{FF2B5EF4-FFF2-40B4-BE49-F238E27FC236}">
-                <a16:creationId xmlns:a16="http://schemas.microsoft.com/office/drawing/2014/main" id="{A1A6A909-052A-4BC8-BD96-C06FE7D0E9D0}"/>
+                <a16:creationId xmlns:a16="http://schemas.microsoft.com/office/drawing/2014/main" id="{EF8A672E-704D-4EBF-B0E9-071B0CEEABD9}"/>
               </a:ext>
             </a:extLst>
           </p:cNvPr>
@@ -3324,7 +3257,7 @@
           <p:cNvPr id="16" name="step-caption-2">
             <a:extLst xmlns:a="http://schemas.openxmlformats.org/drawingml/2006/main">
               <a:ext uri="{FF2B5EF4-FFF2-40B4-BE49-F238E27FC236}">
-                <a16:creationId xmlns:a16="http://schemas.microsoft.com/office/drawing/2014/main" id="{A886325F-580E-4E0D-B481-DBEA3CFDBAC2}"/>
+                <a16:creationId xmlns:a16="http://schemas.microsoft.com/office/drawing/2014/main" id="{8F802D03-5161-486B-A47F-991053E1DB66}"/>
               </a:ext>
             </a:extLst>
           </p:cNvPr>
@@ -3405,7 +3338,7 @@
           <p:cNvPr id="17" name="step-caption-3">
             <a:extLst xmlns:a="http://schemas.openxmlformats.org/drawingml/2006/main">
               <a:ext uri="{FF2B5EF4-FFF2-40B4-BE49-F238E27FC236}">
-                <a16:creationId xmlns:a16="http://schemas.microsoft.com/office/drawing/2014/main" id="{6B5ADF8B-EB0F-42C8-BAC3-F2C008D6A0D5}"/>
+                <a16:creationId xmlns:a16="http://schemas.microsoft.com/office/drawing/2014/main" id="{F505BA31-B6D6-4457-B006-76C58E92B772}"/>
               </a:ext>
             </a:extLst>
           </p:cNvPr>
@@ -3486,7 +3419,7 @@
           <p:cNvPr id="18" name="step-caption-4">
             <a:extLst xmlns:a="http://schemas.openxmlformats.org/drawingml/2006/main">
               <a:ext uri="{FF2B5EF4-FFF2-40B4-BE49-F238E27FC236}">
-                <a16:creationId xmlns:a16="http://schemas.microsoft.com/office/drawing/2014/main" id="{F44D043F-5AD4-4B01-BE9C-9AF14859F458}"/>
+                <a16:creationId xmlns:a16="http://schemas.microsoft.com/office/drawing/2014/main" id="{8B27B059-1AC3-4B45-93FC-8FEB4B4BFF14}"/>
               </a:ext>
             </a:extLst>
           </p:cNvPr>
@@ -3567,7 +3500,7 @@
           <p:cNvPr id="19" name="step-caption-5">
             <a:extLst xmlns:a="http://schemas.openxmlformats.org/drawingml/2006/main">
               <a:ext uri="{FF2B5EF4-FFF2-40B4-BE49-F238E27FC236}">
-                <a16:creationId xmlns:a16="http://schemas.microsoft.com/office/drawing/2014/main" id="{BB864651-5820-4503-9F4B-89BCCB24118E}"/>
+                <a16:creationId xmlns:a16="http://schemas.microsoft.com/office/drawing/2014/main" id="{27632150-6F9E-40FC-AF50-6553CA88311D}"/>
               </a:ext>
             </a:extLst>
           </p:cNvPr>
@@ -3648,7 +3581,7 @@
           <p:cNvPr id="20" name="redis-rule">
             <a:extLst xmlns:a="http://schemas.openxmlformats.org/drawingml/2006/main">
               <a:ext uri="{FF2B5EF4-FFF2-40B4-BE49-F238E27FC236}">
-                <a16:creationId xmlns:a16="http://schemas.microsoft.com/office/drawing/2014/main" id="{FFA09C22-7DE7-4C69-A23C-580A1DDEA2C7}"/>
+                <a16:creationId xmlns:a16="http://schemas.microsoft.com/office/drawing/2014/main" id="{3816EDE4-2EDB-4423-B152-6A2CA3E2029E}"/>
               </a:ext>
             </a:extLst>
           </p:cNvPr>
@@ -3679,7 +3612,7 @@
           <p:cNvPr id="21" name="redis-title">
             <a:extLst xmlns:a="http://schemas.openxmlformats.org/drawingml/2006/main">
               <a:ext uri="{FF2B5EF4-FFF2-40B4-BE49-F238E27FC236}">
-                <a16:creationId xmlns:a16="http://schemas.microsoft.com/office/drawing/2014/main" id="{8ABB57DB-C04F-4EDC-9A74-8FAF68B2AE5D}"/>
+                <a16:creationId xmlns:a16="http://schemas.microsoft.com/office/drawing/2014/main" id="{906D4D99-E2D6-46AF-AFD8-4F0A723B8FD4}"/>
               </a:ext>
             </a:extLst>
           </p:cNvPr>
@@ -3737,7 +3670,7 @@
           <p:cNvPr id="22" name="redis-note">
             <a:extLst xmlns:a="http://schemas.openxmlformats.org/drawingml/2006/main">
               <a:ext uri="{FF2B5EF4-FFF2-40B4-BE49-F238E27FC236}">
-                <a16:creationId xmlns:a16="http://schemas.microsoft.com/office/drawing/2014/main" id="{352DF611-D06A-43D0-BBFE-11CAD30C9547}"/>
+                <a16:creationId xmlns:a16="http://schemas.microsoft.com/office/drawing/2014/main" id="{CA8054A1-46E9-42B5-9969-A724C2AB5467}"/>
               </a:ext>
             </a:extLst>
           </p:cNvPr>
@@ -3795,7 +3728,7 @@
           <p:cNvPr id="23" name="bottom-rule">
             <a:extLst xmlns:a="http://schemas.openxmlformats.org/drawingml/2006/main">
               <a:ext uri="{FF2B5EF4-FFF2-40B4-BE49-F238E27FC236}">
-                <a16:creationId xmlns:a16="http://schemas.microsoft.com/office/drawing/2014/main" id="{4D4FC847-D99E-4AA2-88C4-BEA85B7637F9}"/>
+                <a16:creationId xmlns:a16="http://schemas.microsoft.com/office/drawing/2014/main" id="{EA19A491-DFDD-40ED-83A5-42A82CCD625D}"/>
               </a:ext>
             </a:extLst>
           </p:cNvPr>
@@ -3826,7 +3759,7 @@
           <p:cNvPr id="24" name="footer">
             <a:extLst xmlns:a="http://schemas.openxmlformats.org/drawingml/2006/main">
               <a:ext uri="{FF2B5EF4-FFF2-40B4-BE49-F238E27FC236}">
-                <a16:creationId xmlns:a16="http://schemas.microsoft.com/office/drawing/2014/main" id="{715BF490-F403-4989-9C3A-612DEAF73F44}"/>
+                <a16:creationId xmlns:a16="http://schemas.microsoft.com/office/drawing/2014/main" id="{1C827B47-4724-4520-95FC-8576A7273E3A}"/>
               </a:ext>
             </a:extLst>
           </p:cNvPr>
@@ -3884,7 +3817,7 @@
           <p:cNvPr id="25" name="page">
             <a:extLst xmlns:a="http://schemas.openxmlformats.org/drawingml/2006/main">
               <a:ext uri="{FF2B5EF4-FFF2-40B4-BE49-F238E27FC236}">
-                <a16:creationId xmlns:a16="http://schemas.microsoft.com/office/drawing/2014/main" id="{6DEB37FA-09D9-426C-80DA-E50E380DC997}"/>
+                <a16:creationId xmlns:a16="http://schemas.microsoft.com/office/drawing/2014/main" id="{D9793841-818A-4F1F-A525-E656D99B1EF0}"/>
               </a:ext>
             </a:extLst>
           </p:cNvPr>
@@ -3932,7 +3865,7 @@
                 <a:ea typeface="Arial"/>
                 <a:cs typeface="Arial"/>
               </a:rPr>
-              <a:t>03 / 07</a:t>
+              <a:t>03 / 06</a:t>
             </a:r>
           </a:p>
         </p:txBody>
@@ -3940,7 +3873,7 @@
     </p:spTree>
     <p:extLst>
       <p:ext uri="{BB962C8B-B14F-4D97-AF65-F5344CB8AC3E}">
-        <p14:creationId xmlns:p14="http://schemas.microsoft.com/office/powerpoint/2010/main" val="2124127794"/>
+        <p14:creationId xmlns:p14="http://schemas.microsoft.com/office/powerpoint/2010/main" val="140844760"/>
       </p:ext>
     </p:extLst>
   </p:cSld>
@@ -3974,7 +3907,7 @@
           <p:cNvPr id="22" name="section">
             <a:extLst xmlns:a="http://schemas.openxmlformats.org/drawingml/2006/main">
               <a:ext uri="{FF2B5EF4-FFF2-40B4-BE49-F238E27FC236}">
-                <a16:creationId xmlns:a16="http://schemas.microsoft.com/office/drawing/2014/main" id="{09D2C6E6-180E-411E-88FA-BF39297BA3B6}"/>
+                <a16:creationId xmlns:a16="http://schemas.microsoft.com/office/drawing/2014/main" id="{E0B9536B-EB1D-4D26-AE46-A36FC4DFC996}"/>
               </a:ext>
             </a:extLst>
           </p:cNvPr>
@@ -4032,7 +3965,7 @@
           <p:cNvPr id="2" name="title">
             <a:extLst xmlns:a="http://schemas.openxmlformats.org/drawingml/2006/main">
               <a:ext uri="{FF2B5EF4-FFF2-40B4-BE49-F238E27FC236}">
-                <a16:creationId xmlns:a16="http://schemas.microsoft.com/office/drawing/2014/main" id="{32770995-3468-4D3D-B8F0-B63B7B96B43B}"/>
+                <a16:creationId xmlns:a16="http://schemas.microsoft.com/office/drawing/2014/main" id="{78DB39B4-4776-45F3-8CFB-230FF6F532DD}"/>
               </a:ext>
             </a:extLst>
           </p:cNvPr>
@@ -4090,7 +4023,7 @@
           <p:cNvPr id="3" name="id-label">
             <a:extLst xmlns:a="http://schemas.openxmlformats.org/drawingml/2006/main">
               <a:ext uri="{FF2B5EF4-FFF2-40B4-BE49-F238E27FC236}">
-                <a16:creationId xmlns:a16="http://schemas.microsoft.com/office/drawing/2014/main" id="{4C66F2A7-FFC9-4DD8-BDE3-3BCF65A3DA08}"/>
+                <a16:creationId xmlns:a16="http://schemas.microsoft.com/office/drawing/2014/main" id="{42586CE9-6F50-4047-B10E-DC124ACAA5F6}"/>
               </a:ext>
             </a:extLst>
           </p:cNvPr>
@@ -4148,7 +4081,7 @@
           <p:cNvPr id="4" name="row1-num">
             <a:extLst xmlns:a="http://schemas.openxmlformats.org/drawingml/2006/main">
               <a:ext uri="{FF2B5EF4-FFF2-40B4-BE49-F238E27FC236}">
-                <a16:creationId xmlns:a16="http://schemas.microsoft.com/office/drawing/2014/main" id="{04DFB667-F226-4948-A6DB-BF049373F48B}"/>
+                <a16:creationId xmlns:a16="http://schemas.microsoft.com/office/drawing/2014/main" id="{D3A7B560-1FEB-40BC-BDFE-339E3DF5F30C}"/>
               </a:ext>
             </a:extLst>
           </p:cNvPr>
@@ -4206,7 +4139,7 @@
           <p:cNvPr id="5" name="row1-label">
             <a:extLst xmlns:a="http://schemas.openxmlformats.org/drawingml/2006/main">
               <a:ext uri="{FF2B5EF4-FFF2-40B4-BE49-F238E27FC236}">
-                <a16:creationId xmlns:a16="http://schemas.microsoft.com/office/drawing/2014/main" id="{4D753003-8DC3-48A3-9F91-D1D1E4CC4C13}"/>
+                <a16:creationId xmlns:a16="http://schemas.microsoft.com/office/drawing/2014/main" id="{8DAD4E70-732A-4ECC-895B-2B9A20EC2032}"/>
               </a:ext>
             </a:extLst>
           </p:cNvPr>
@@ -4264,7 +4197,7 @@
           <p:cNvPr id="6" name="row1-value">
             <a:extLst xmlns:a="http://schemas.openxmlformats.org/drawingml/2006/main">
               <a:ext uri="{FF2B5EF4-FFF2-40B4-BE49-F238E27FC236}">
-                <a16:creationId xmlns:a16="http://schemas.microsoft.com/office/drawing/2014/main" id="{70874106-3CC0-4125-A4C9-22961D101A01}"/>
+                <a16:creationId xmlns:a16="http://schemas.microsoft.com/office/drawing/2014/main" id="{6C2D74FC-BB2E-4BEC-892D-29E05F17DE7C}"/>
               </a:ext>
             </a:extLst>
           </p:cNvPr>
@@ -4322,7 +4255,7 @@
           <p:cNvPr id="7" name="line1">
             <a:extLst xmlns:a="http://schemas.openxmlformats.org/drawingml/2006/main">
               <a:ext uri="{FF2B5EF4-FFF2-40B4-BE49-F238E27FC236}">
-                <a16:creationId xmlns:a16="http://schemas.microsoft.com/office/drawing/2014/main" id="{74FEDCA4-0BDB-4FED-9F50-39C836378FCB}"/>
+                <a16:creationId xmlns:a16="http://schemas.microsoft.com/office/drawing/2014/main" id="{48F6111A-FA30-412E-87B0-EE8DA9E0A4BF}"/>
               </a:ext>
             </a:extLst>
           </p:cNvPr>
@@ -4353,7 +4286,7 @@
           <p:cNvPr id="8" name="row2-num">
             <a:extLst xmlns:a="http://schemas.openxmlformats.org/drawingml/2006/main">
               <a:ext uri="{FF2B5EF4-FFF2-40B4-BE49-F238E27FC236}">
-                <a16:creationId xmlns:a16="http://schemas.microsoft.com/office/drawing/2014/main" id="{50604E22-BA2E-49B9-8416-7BC8D90281CE}"/>
+                <a16:creationId xmlns:a16="http://schemas.microsoft.com/office/drawing/2014/main" id="{76E4F5D1-2344-4EB7-A8DF-1BFBF082B7B8}"/>
               </a:ext>
             </a:extLst>
           </p:cNvPr>
@@ -4411,7 +4344,7 @@
           <p:cNvPr id="9" name="row2-label">
             <a:extLst xmlns:a="http://schemas.openxmlformats.org/drawingml/2006/main">
               <a:ext uri="{FF2B5EF4-FFF2-40B4-BE49-F238E27FC236}">
-                <a16:creationId xmlns:a16="http://schemas.microsoft.com/office/drawing/2014/main" id="{67ED1C8B-AE9D-4F74-9519-5204EFABDDAF}"/>
+                <a16:creationId xmlns:a16="http://schemas.microsoft.com/office/drawing/2014/main" id="{D63BED1D-B8A9-41C5-8B11-3F53D2268B8C}"/>
               </a:ext>
             </a:extLst>
           </p:cNvPr>
@@ -4469,7 +4402,7 @@
           <p:cNvPr id="10" name="row2-value">
             <a:extLst xmlns:a="http://schemas.openxmlformats.org/drawingml/2006/main">
               <a:ext uri="{FF2B5EF4-FFF2-40B4-BE49-F238E27FC236}">
-                <a16:creationId xmlns:a16="http://schemas.microsoft.com/office/drawing/2014/main" id="{05BBC236-BAB3-416C-8E2A-F68A9D2EDA3B}"/>
+                <a16:creationId xmlns:a16="http://schemas.microsoft.com/office/drawing/2014/main" id="{4564F4BE-3F81-4D08-A496-092AE765DB74}"/>
               </a:ext>
             </a:extLst>
           </p:cNvPr>
@@ -4527,7 +4460,7 @@
           <p:cNvPr id="11" name="line2">
             <a:extLst xmlns:a="http://schemas.openxmlformats.org/drawingml/2006/main">
               <a:ext uri="{FF2B5EF4-FFF2-40B4-BE49-F238E27FC236}">
-                <a16:creationId xmlns:a16="http://schemas.microsoft.com/office/drawing/2014/main" id="{D7983349-1031-4F75-AE78-F95F736BC928}"/>
+                <a16:creationId xmlns:a16="http://schemas.microsoft.com/office/drawing/2014/main" id="{44183FDD-DB3F-4F08-9538-FE2540687DF8}"/>
               </a:ext>
             </a:extLst>
           </p:cNvPr>
@@ -4558,7 +4491,7 @@
           <p:cNvPr id="12" name="row3-num">
             <a:extLst xmlns:a="http://schemas.openxmlformats.org/drawingml/2006/main">
               <a:ext uri="{FF2B5EF4-FFF2-40B4-BE49-F238E27FC236}">
-                <a16:creationId xmlns:a16="http://schemas.microsoft.com/office/drawing/2014/main" id="{BBCFB417-11CC-4D3D-9297-42F1CD126CD0}"/>
+                <a16:creationId xmlns:a16="http://schemas.microsoft.com/office/drawing/2014/main" id="{786B2CEE-D875-4767-9614-217E56712EE2}"/>
               </a:ext>
             </a:extLst>
           </p:cNvPr>
@@ -4616,7 +4549,7 @@
           <p:cNvPr id="13" name="row3-label">
             <a:extLst xmlns:a="http://schemas.openxmlformats.org/drawingml/2006/main">
               <a:ext uri="{FF2B5EF4-FFF2-40B4-BE49-F238E27FC236}">
-                <a16:creationId xmlns:a16="http://schemas.microsoft.com/office/drawing/2014/main" id="{0CC5E1AB-3311-4164-A7E6-43786CA1B4AC}"/>
+                <a16:creationId xmlns:a16="http://schemas.microsoft.com/office/drawing/2014/main" id="{07280732-74B4-4CA4-886B-E18E6FB2854A}"/>
               </a:ext>
             </a:extLst>
           </p:cNvPr>
@@ -4674,7 +4607,7 @@
           <p:cNvPr id="14" name="row3-value">
             <a:extLst xmlns:a="http://schemas.openxmlformats.org/drawingml/2006/main">
               <a:ext uri="{FF2B5EF4-FFF2-40B4-BE49-F238E27FC236}">
-                <a16:creationId xmlns:a16="http://schemas.microsoft.com/office/drawing/2014/main" id="{339C1EB3-EB99-4AE6-8706-EDF67E3A7812}"/>
+                <a16:creationId xmlns:a16="http://schemas.microsoft.com/office/drawing/2014/main" id="{4AE3C128-E570-4C76-B441-085F79585464}"/>
               </a:ext>
             </a:extLst>
           </p:cNvPr>
@@ -4732,7 +4665,7 @@
           <p:cNvPr id="15" name="line3">
             <a:extLst xmlns:a="http://schemas.openxmlformats.org/drawingml/2006/main">
               <a:ext uri="{FF2B5EF4-FFF2-40B4-BE49-F238E27FC236}">
-                <a16:creationId xmlns:a16="http://schemas.microsoft.com/office/drawing/2014/main" id="{B5700E0B-9A31-41BD-883F-F24A9C45A553}"/>
+                <a16:creationId xmlns:a16="http://schemas.microsoft.com/office/drawing/2014/main" id="{E72C4BA5-BEF9-4938-BB43-A3C0F3B989B2}"/>
               </a:ext>
             </a:extLst>
           </p:cNvPr>
@@ -4763,7 +4696,7 @@
           <p:cNvPr id="16" name="row4-num">
             <a:extLst xmlns:a="http://schemas.openxmlformats.org/drawingml/2006/main">
               <a:ext uri="{FF2B5EF4-FFF2-40B4-BE49-F238E27FC236}">
-                <a16:creationId xmlns:a16="http://schemas.microsoft.com/office/drawing/2014/main" id="{60933F08-BE6E-4BF5-8BD2-0F1C231201CF}"/>
+                <a16:creationId xmlns:a16="http://schemas.microsoft.com/office/drawing/2014/main" id="{04FE91C6-62BE-40A5-A9DB-453137BE1C6A}"/>
               </a:ext>
             </a:extLst>
           </p:cNvPr>
@@ -4821,7 +4754,7 @@
           <p:cNvPr id="17" name="row4-label">
             <a:extLst xmlns:a="http://schemas.openxmlformats.org/drawingml/2006/main">
               <a:ext uri="{FF2B5EF4-FFF2-40B4-BE49-F238E27FC236}">
-                <a16:creationId xmlns:a16="http://schemas.microsoft.com/office/drawing/2014/main" id="{AF030219-15CF-4BFF-8CF3-56A657077753}"/>
+                <a16:creationId xmlns:a16="http://schemas.microsoft.com/office/drawing/2014/main" id="{7CA6A94C-43E6-4C33-9CBB-AEDBDA959D20}"/>
               </a:ext>
             </a:extLst>
           </p:cNvPr>
@@ -4879,7 +4812,7 @@
           <p:cNvPr id="18" name="row4-value">
             <a:extLst xmlns:a="http://schemas.openxmlformats.org/drawingml/2006/main">
               <a:ext uri="{FF2B5EF4-FFF2-40B4-BE49-F238E27FC236}">
-                <a16:creationId xmlns:a16="http://schemas.microsoft.com/office/drawing/2014/main" id="{A24EE892-9045-4432-9151-289DC882882A}"/>
+                <a16:creationId xmlns:a16="http://schemas.microsoft.com/office/drawing/2014/main" id="{3669861C-EDEF-40B8-ABCB-60A1B76C2F23}"/>
               </a:ext>
             </a:extLst>
           </p:cNvPr>
@@ -4937,7 +4870,7 @@
           <p:cNvPr id="19" name="bottom-rule">
             <a:extLst xmlns:a="http://schemas.openxmlformats.org/drawingml/2006/main">
               <a:ext uri="{FF2B5EF4-FFF2-40B4-BE49-F238E27FC236}">
-                <a16:creationId xmlns:a16="http://schemas.microsoft.com/office/drawing/2014/main" id="{BB6AF20E-2EE1-45FC-A309-9687648D5C69}"/>
+                <a16:creationId xmlns:a16="http://schemas.microsoft.com/office/drawing/2014/main" id="{3374352E-5FBF-4EAA-B7D1-91B52C40CE75}"/>
               </a:ext>
             </a:extLst>
           </p:cNvPr>
@@ -4968,7 +4901,7 @@
           <p:cNvPr id="20" name="footer">
             <a:extLst xmlns:a="http://schemas.openxmlformats.org/drawingml/2006/main">
               <a:ext uri="{FF2B5EF4-FFF2-40B4-BE49-F238E27FC236}">
-                <a16:creationId xmlns:a16="http://schemas.microsoft.com/office/drawing/2014/main" id="{F3EDBA07-DB6B-4639-A1EF-02751251D622}"/>
+                <a16:creationId xmlns:a16="http://schemas.microsoft.com/office/drawing/2014/main" id="{7BBE1701-9607-43CB-8C1A-E6374A28313F}"/>
               </a:ext>
             </a:extLst>
           </p:cNvPr>
@@ -5026,7 +4959,7 @@
           <p:cNvPr id="21" name="page">
             <a:extLst xmlns:a="http://schemas.openxmlformats.org/drawingml/2006/main">
               <a:ext uri="{FF2B5EF4-FFF2-40B4-BE49-F238E27FC236}">
-                <a16:creationId xmlns:a16="http://schemas.microsoft.com/office/drawing/2014/main" id="{994ED1B1-1C84-4106-A99F-EB573AB6B63E}"/>
+                <a16:creationId xmlns:a16="http://schemas.microsoft.com/office/drawing/2014/main" id="{FECBDB60-B639-427F-8CF2-309167DE778D}"/>
               </a:ext>
             </a:extLst>
           </p:cNvPr>
@@ -5074,7 +5007,7 @@
                 <a:ea typeface="Arial"/>
                 <a:cs typeface="Arial"/>
               </a:rPr>
-              <a:t>04 / 07</a:t>
+              <a:t>04 / 06</a:t>
             </a:r>
           </a:p>
         </p:txBody>
@@ -5082,7 +5015,7 @@
     </p:spTree>
     <p:extLst>
       <p:ext uri="{BB962C8B-B14F-4D97-AF65-F5344CB8AC3E}">
-        <p14:creationId xmlns:p14="http://schemas.microsoft.com/office/powerpoint/2010/main" val="1682489813"/>
+        <p14:creationId xmlns:p14="http://schemas.microsoft.com/office/powerpoint/2010/main" val="20414727"/>
       </p:ext>
     </p:extLst>
   </p:cSld>
@@ -5116,7 +5049,7 @@
           <p:cNvPr id="12" name="section">
             <a:extLst xmlns:a="http://schemas.openxmlformats.org/drawingml/2006/main">
               <a:ext uri="{FF2B5EF4-FFF2-40B4-BE49-F238E27FC236}">
-                <a16:creationId xmlns:a16="http://schemas.microsoft.com/office/drawing/2014/main" id="{939DB530-6EAF-45F7-9FF3-68718C2F3BBE}"/>
+                <a16:creationId xmlns:a16="http://schemas.microsoft.com/office/drawing/2014/main" id="{1BF68689-F005-45E9-98F0-5648BFB40781}"/>
               </a:ext>
             </a:extLst>
           </p:cNvPr>
@@ -5174,7 +5107,7 @@
           <p:cNvPr id="2" name="title">
             <a:extLst xmlns:a="http://schemas.openxmlformats.org/drawingml/2006/main">
               <a:ext uri="{FF2B5EF4-FFF2-40B4-BE49-F238E27FC236}">
-                <a16:creationId xmlns:a16="http://schemas.microsoft.com/office/drawing/2014/main" id="{827D4BF6-D04D-4076-8E16-D20AC824E57E}"/>
+                <a16:creationId xmlns:a16="http://schemas.microsoft.com/office/drawing/2014/main" id="{8C6AB892-2F4D-4CF6-929D-5CB02535D5C4}"/>
               </a:ext>
             </a:extLst>
           </p:cNvPr>
@@ -5232,7 +5165,7 @@
           <p:cNvPr id="3" name="top-rule">
             <a:extLst xmlns:a="http://schemas.openxmlformats.org/drawingml/2006/main">
               <a:ext uri="{FF2B5EF4-FFF2-40B4-BE49-F238E27FC236}">
-                <a16:creationId xmlns:a16="http://schemas.microsoft.com/office/drawing/2014/main" id="{366C616C-EEA6-4FCA-9874-41C4B78CC779}"/>
+                <a16:creationId xmlns:a16="http://schemas.microsoft.com/office/drawing/2014/main" id="{BEC7F2FB-3070-4EA5-8B34-A9FCFE3E8180}"/>
               </a:ext>
             </a:extLst>
           </p:cNvPr>
@@ -5263,7 +5196,7 @@
           <p:cNvPr id="4" name="left-head">
             <a:extLst xmlns:a="http://schemas.openxmlformats.org/drawingml/2006/main">
               <a:ext uri="{FF2B5EF4-FFF2-40B4-BE49-F238E27FC236}">
-                <a16:creationId xmlns:a16="http://schemas.microsoft.com/office/drawing/2014/main" id="{5A506101-0ABD-4343-A71D-894682668E4F}"/>
+                <a16:creationId xmlns:a16="http://schemas.microsoft.com/office/drawing/2014/main" id="{903ABA2B-81DE-4006-9A93-22C84EF39186}"/>
               </a:ext>
             </a:extLst>
           </p:cNvPr>
@@ -5321,7 +5254,7 @@
           <p:cNvPr id="5" name="left-text">
             <a:extLst xmlns:a="http://schemas.openxmlformats.org/drawingml/2006/main">
               <a:ext uri="{FF2B5EF4-FFF2-40B4-BE49-F238E27FC236}">
-                <a16:creationId xmlns:a16="http://schemas.microsoft.com/office/drawing/2014/main" id="{3BEB7B7F-E6A2-4584-ABEB-C621126987EF}"/>
+                <a16:creationId xmlns:a16="http://schemas.microsoft.com/office/drawing/2014/main" id="{B14D2F4E-F245-43F4-A450-2C0B2E5AC8A0}"/>
               </a:ext>
             </a:extLst>
           </p:cNvPr>
@@ -5476,7 +5409,7 @@
           <p:cNvPr id="6" name="mid-rule">
             <a:extLst xmlns:a="http://schemas.openxmlformats.org/drawingml/2006/main">
               <a:ext uri="{FF2B5EF4-FFF2-40B4-BE49-F238E27FC236}">
-                <a16:creationId xmlns:a16="http://schemas.microsoft.com/office/drawing/2014/main" id="{B5FA4517-2BD7-4C0D-9C60-CB030797493D}"/>
+                <a16:creationId xmlns:a16="http://schemas.microsoft.com/office/drawing/2014/main" id="{A00A3C56-2FF7-4130-8022-5B08EAFC7C6A}"/>
               </a:ext>
             </a:extLst>
           </p:cNvPr>
@@ -5507,7 +5440,7 @@
           <p:cNvPr id="7" name="right-head">
             <a:extLst xmlns:a="http://schemas.openxmlformats.org/drawingml/2006/main">
               <a:ext uri="{FF2B5EF4-FFF2-40B4-BE49-F238E27FC236}">
-                <a16:creationId xmlns:a16="http://schemas.microsoft.com/office/drawing/2014/main" id="{CA519450-7D77-4FCA-A49B-5FFF55DE20BF}"/>
+                <a16:creationId xmlns:a16="http://schemas.microsoft.com/office/drawing/2014/main" id="{F5B8991E-B747-4AC3-999B-EF80D19BDA60}"/>
               </a:ext>
             </a:extLst>
           </p:cNvPr>
@@ -5565,7 +5498,7 @@
           <p:cNvPr id="8" name="right-text">
             <a:extLst xmlns:a="http://schemas.openxmlformats.org/drawingml/2006/main">
               <a:ext uri="{FF2B5EF4-FFF2-40B4-BE49-F238E27FC236}">
-                <a16:creationId xmlns:a16="http://schemas.microsoft.com/office/drawing/2014/main" id="{B670F929-9140-4A6D-8C09-7DE2D9C9F701}"/>
+                <a16:creationId xmlns:a16="http://schemas.microsoft.com/office/drawing/2014/main" id="{F11DB034-FA8A-4133-963C-F566628F1514}"/>
               </a:ext>
             </a:extLst>
           </p:cNvPr>
@@ -5697,7 +5630,7 @@
           <p:cNvPr id="9" name="bottom-rule">
             <a:extLst xmlns:a="http://schemas.openxmlformats.org/drawingml/2006/main">
               <a:ext uri="{FF2B5EF4-FFF2-40B4-BE49-F238E27FC236}">
-                <a16:creationId xmlns:a16="http://schemas.microsoft.com/office/drawing/2014/main" id="{BBA430DC-8D4D-425B-975B-FCA96D2B2ECD}"/>
+                <a16:creationId xmlns:a16="http://schemas.microsoft.com/office/drawing/2014/main" id="{C393ECEE-5B18-40B7-A964-A395DFFE1218}"/>
               </a:ext>
             </a:extLst>
           </p:cNvPr>
@@ -5728,7 +5661,7 @@
           <p:cNvPr id="10" name="footer">
             <a:extLst xmlns:a="http://schemas.openxmlformats.org/drawingml/2006/main">
               <a:ext uri="{FF2B5EF4-FFF2-40B4-BE49-F238E27FC236}">
-                <a16:creationId xmlns:a16="http://schemas.microsoft.com/office/drawing/2014/main" id="{25372CB3-611D-49C5-97FE-CCA6A07D1130}"/>
+                <a16:creationId xmlns:a16="http://schemas.microsoft.com/office/drawing/2014/main" id="{A5C88D7E-0B3E-48F9-AEEC-DAAFA9383056}"/>
               </a:ext>
             </a:extLst>
           </p:cNvPr>
@@ -5786,7 +5719,7 @@
           <p:cNvPr id="11" name="page">
             <a:extLst xmlns:a="http://schemas.openxmlformats.org/drawingml/2006/main">
               <a:ext uri="{FF2B5EF4-FFF2-40B4-BE49-F238E27FC236}">
-                <a16:creationId xmlns:a16="http://schemas.microsoft.com/office/drawing/2014/main" id="{28BED551-5208-4639-8822-48A4ED46CEE3}"/>
+                <a16:creationId xmlns:a16="http://schemas.microsoft.com/office/drawing/2014/main" id="{4D1E86DD-C8EB-4515-9AA6-23CDE9424482}"/>
               </a:ext>
             </a:extLst>
           </p:cNvPr>
@@ -5834,7 +5767,7 @@
                 <a:ea typeface="Arial"/>
                 <a:cs typeface="Arial"/>
               </a:rPr>
-              <a:t>05 / 07</a:t>
+              <a:t>05 / 06</a:t>
             </a:r>
           </a:p>
         </p:txBody>
@@ -5842,7 +5775,7 @@
     </p:spTree>
     <p:extLst>
       <p:ext uri="{BB962C8B-B14F-4D97-AF65-F5344CB8AC3E}">
-        <p14:creationId xmlns:p14="http://schemas.microsoft.com/office/powerpoint/2010/main" val="1275720877"/>
+        <p14:creationId xmlns:p14="http://schemas.microsoft.com/office/powerpoint/2010/main" val="337838650"/>
       </p:ext>
     </p:extLst>
   </p:cSld>
@@ -5876,7 +5809,7 @@
           <p:cNvPr id="15" name="section">
             <a:extLst xmlns:a="http://schemas.openxmlformats.org/drawingml/2006/main">
               <a:ext uri="{FF2B5EF4-FFF2-40B4-BE49-F238E27FC236}">
-                <a16:creationId xmlns:a16="http://schemas.microsoft.com/office/drawing/2014/main" id="{5E7D6FDC-3DA8-4B60-8D2F-C2E58A61DE45}"/>
+                <a16:creationId xmlns:a16="http://schemas.microsoft.com/office/drawing/2014/main" id="{CD7F5024-494A-4C4D-8505-C94CD46E1F41}"/>
               </a:ext>
             </a:extLst>
           </p:cNvPr>
@@ -5934,7 +5867,7 @@
           <p:cNvPr id="2" name="title">
             <a:extLst xmlns:a="http://schemas.openxmlformats.org/drawingml/2006/main">
               <a:ext uri="{FF2B5EF4-FFF2-40B4-BE49-F238E27FC236}">
-                <a16:creationId xmlns:a16="http://schemas.microsoft.com/office/drawing/2014/main" id="{845D2E3A-2057-471F-9F65-B92F8E00FB13}"/>
+                <a16:creationId xmlns:a16="http://schemas.microsoft.com/office/drawing/2014/main" id="{6CC06465-EC0E-4D7E-935C-0C4953D22AFF}"/>
               </a:ext>
             </a:extLst>
           </p:cNvPr>
@@ -5982,7 +5915,7 @@
                 <a:ea typeface="Arial"/>
                 <a:cs typeface="Arial"/>
               </a:rPr>
-              <a:t>Что проверено — и что ещё нет</a:t>
+              <a:t>Локальная проверка работоспособности</a:t>
             </a:r>
           </a:p>
         </p:txBody>
@@ -5992,7 +5925,7 @@
           <p:cNvPr id="3" name="top-rule">
             <a:extLst xmlns:a="http://schemas.openxmlformats.org/drawingml/2006/main">
               <a:ext uri="{FF2B5EF4-FFF2-40B4-BE49-F238E27FC236}">
-                <a16:creationId xmlns:a16="http://schemas.microsoft.com/office/drawing/2014/main" id="{E251559F-B6C1-462D-B72D-C29046D4829F}"/>
+                <a16:creationId xmlns:a16="http://schemas.microsoft.com/office/drawing/2014/main" id="{A47E49AC-4222-4051-9637-1C28136D8A6D}"/>
               </a:ext>
             </a:extLst>
           </p:cNvPr>
@@ -6023,7 +5956,7 @@
           <p:cNvPr id="4" name="count">
             <a:extLst xmlns:a="http://schemas.openxmlformats.org/drawingml/2006/main">
               <a:ext uri="{FF2B5EF4-FFF2-40B4-BE49-F238E27FC236}">
-                <a16:creationId xmlns:a16="http://schemas.microsoft.com/office/drawing/2014/main" id="{AC27C05B-8621-408A-A9A4-C4B460E137BE}"/>
+                <a16:creationId xmlns:a16="http://schemas.microsoft.com/office/drawing/2014/main" id="{87DF52F8-7E72-4F44-AB9B-1D4A11818DF8}"/>
               </a:ext>
             </a:extLst>
           </p:cNvPr>
@@ -6081,7 +6014,7 @@
           <p:cNvPr id="5" name="count-label">
             <a:extLst xmlns:a="http://schemas.openxmlformats.org/drawingml/2006/main">
               <a:ext uri="{FF2B5EF4-FFF2-40B4-BE49-F238E27FC236}">
-                <a16:creationId xmlns:a16="http://schemas.microsoft.com/office/drawing/2014/main" id="{8BE4F5EE-675B-48E7-A057-F9014A376159}"/>
+                <a16:creationId xmlns:a16="http://schemas.microsoft.com/office/drawing/2014/main" id="{325625F2-6237-4701-A055-D0E48EBA014F}"/>
               </a:ext>
             </a:extLst>
           </p:cNvPr>
@@ -6139,7 +6072,7 @@
           <p:cNvPr id="6" name="verified">
             <a:extLst xmlns:a="http://schemas.openxmlformats.org/drawingml/2006/main">
               <a:ext uri="{FF2B5EF4-FFF2-40B4-BE49-F238E27FC236}">
-                <a16:creationId xmlns:a16="http://schemas.microsoft.com/office/drawing/2014/main" id="{C104CDF2-7553-4A69-BCAC-352532548737}"/>
+                <a16:creationId xmlns:a16="http://schemas.microsoft.com/office/drawing/2014/main" id="{E2C83CEB-F73F-4397-ABB5-EAF81F8F81AB}"/>
               </a:ext>
             </a:extLst>
           </p:cNvPr>
@@ -6220,7 +6153,7 @@
           <p:cNvPr id="7" name="divider">
             <a:extLst xmlns:a="http://schemas.openxmlformats.org/drawingml/2006/main">
               <a:ext uri="{FF2B5EF4-FFF2-40B4-BE49-F238E27FC236}">
-                <a16:creationId xmlns:a16="http://schemas.microsoft.com/office/drawing/2014/main" id="{A0563840-E1DF-4459-9712-7D647578CFC5}"/>
+                <a16:creationId xmlns:a16="http://schemas.microsoft.com/office/drawing/2014/main" id="{3E938E4F-F9BE-4BEC-A1C1-2589BE815D78}"/>
               </a:ext>
             </a:extLst>
           </p:cNvPr>
@@ -6251,7 +6184,7 @@
           <p:cNvPr id="8" name="notyet-label">
             <a:extLst xmlns:a="http://schemas.openxmlformats.org/drawingml/2006/main">
               <a:ext uri="{FF2B5EF4-FFF2-40B4-BE49-F238E27FC236}">
-                <a16:creationId xmlns:a16="http://schemas.microsoft.com/office/drawing/2014/main" id="{5F8DE9F6-616C-40A6-B71F-35785849FFAD}"/>
+                <a16:creationId xmlns:a16="http://schemas.microsoft.com/office/drawing/2014/main" id="{B3DD58B1-C6A6-43A4-8B05-6E6BB8D40461}"/>
               </a:ext>
             </a:extLst>
           </p:cNvPr>
@@ -6299,7 +6232,7 @@
                 <a:ea typeface="Arial"/>
                 <a:cs typeface="Arial"/>
               </a:rPr>
-              <a:t>Открытые проверки</a:t>
+              <a:t>Границы оценки</a:t>
             </a:r>
           </a:p>
         </p:txBody>
@@ -6309,7 +6242,7 @@
           <p:cNvPr id="9" name="notyet-1">
             <a:extLst xmlns:a="http://schemas.openxmlformats.org/drawingml/2006/main">
               <a:ext uri="{FF2B5EF4-FFF2-40B4-BE49-F238E27FC236}">
-                <a16:creationId xmlns:a16="http://schemas.microsoft.com/office/drawing/2014/main" id="{635BD2CB-8C94-42C2-91F7-952B64B5EC5E}"/>
+                <a16:creationId xmlns:a16="http://schemas.microsoft.com/office/drawing/2014/main" id="{0246997A-4436-48EC-812F-0773C6B6DD71}"/>
               </a:ext>
             </a:extLst>
           </p:cNvPr>
@@ -6413,7 +6346,7 @@
           <p:cNvPr id="10" name="red-rule">
             <a:extLst xmlns:a="http://schemas.openxmlformats.org/drawingml/2006/main">
               <a:ext uri="{FF2B5EF4-FFF2-40B4-BE49-F238E27FC236}">
-                <a16:creationId xmlns:a16="http://schemas.microsoft.com/office/drawing/2014/main" id="{CE7A2F41-04B2-4794-B2DE-2B7ED063C63F}"/>
+                <a16:creationId xmlns:a16="http://schemas.microsoft.com/office/drawing/2014/main" id="{A6D27115-D222-4909-8279-6899BBBC3E02}"/>
               </a:ext>
             </a:extLst>
           </p:cNvPr>
@@ -6444,7 +6377,7 @@
           <p:cNvPr id="11" name="notyet-2">
             <a:extLst xmlns:a="http://schemas.openxmlformats.org/drawingml/2006/main">
               <a:ext uri="{FF2B5EF4-FFF2-40B4-BE49-F238E27FC236}">
-                <a16:creationId xmlns:a16="http://schemas.microsoft.com/office/drawing/2014/main" id="{75B18C35-FE40-4ADE-8675-0101C0CDFF44}"/>
+                <a16:creationId xmlns:a16="http://schemas.microsoft.com/office/drawing/2014/main" id="{E2AA02C1-11C1-401B-8D6A-F25C0C466B61}"/>
               </a:ext>
             </a:extLst>
           </p:cNvPr>
@@ -6525,7 +6458,7 @@
           <p:cNvPr id="12" name="bottom-rule">
             <a:extLst xmlns:a="http://schemas.openxmlformats.org/drawingml/2006/main">
               <a:ext uri="{FF2B5EF4-FFF2-40B4-BE49-F238E27FC236}">
-                <a16:creationId xmlns:a16="http://schemas.microsoft.com/office/drawing/2014/main" id="{C3BDF9D8-AAB9-4320-8037-133688C5F041}"/>
+                <a16:creationId xmlns:a16="http://schemas.microsoft.com/office/drawing/2014/main" id="{91F23BB8-06A4-455B-8FA5-BC766FA90406}"/>
               </a:ext>
             </a:extLst>
           </p:cNvPr>
@@ -6556,7 +6489,7 @@
           <p:cNvPr id="13" name="source">
             <a:extLst xmlns:a="http://schemas.openxmlformats.org/drawingml/2006/main">
               <a:ext uri="{FF2B5EF4-FFF2-40B4-BE49-F238E27FC236}">
-                <a16:creationId xmlns:a16="http://schemas.microsoft.com/office/drawing/2014/main" id="{5BBFEC9A-3EE7-4E41-B101-D1F2924848B3}"/>
+                <a16:creationId xmlns:a16="http://schemas.microsoft.com/office/drawing/2014/main" id="{A1F7FC08-9B50-4D18-A6C7-0E5433E17470}"/>
               </a:ext>
             </a:extLst>
           </p:cNvPr>
@@ -6614,7 +6547,7 @@
           <p:cNvPr id="14" name="page">
             <a:extLst xmlns:a="http://schemas.openxmlformats.org/drawingml/2006/main">
               <a:ext uri="{FF2B5EF4-FFF2-40B4-BE49-F238E27FC236}">
-                <a16:creationId xmlns:a16="http://schemas.microsoft.com/office/drawing/2014/main" id="{85F4D40F-A66A-457D-9168-B0F012FFB5F1}"/>
+                <a16:creationId xmlns:a16="http://schemas.microsoft.com/office/drawing/2014/main" id="{2A11F658-9FC4-48C8-8AF7-4ED3393E2328}"/>
               </a:ext>
             </a:extLst>
           </p:cNvPr>
@@ -6662,7 +6595,7 @@
                 <a:ea typeface="Arial"/>
                 <a:cs typeface="Arial"/>
               </a:rPr>
-              <a:t>06 / 07</a:t>
+              <a:t>06 / 06</a:t>
             </a:r>
           </a:p>
         </p:txBody>
@@ -6670,827 +6603,7 @@
     </p:spTree>
     <p:extLst>
       <p:ext uri="{BB962C8B-B14F-4D97-AF65-F5344CB8AC3E}">
-        <p14:creationId xmlns:p14="http://schemas.microsoft.com/office/powerpoint/2010/main" val="1146877911"/>
-      </p:ext>
-    </p:extLst>
-  </p:cSld>
-  <p:transition>
-    <p:fade/>
-  </p:transition>
-</p:sld>
-</file>
-
-<file path=ppt/slides/slide7.xml><?xml version="1.0" encoding="utf-8"?>
-<p:sld xmlns:p="http://schemas.openxmlformats.org/presentationml/2006/main">
-  <p:cSld>
-    <p:bg>
-      <p:bgPr>
-        <a:solidFill xmlns:a="http://schemas.openxmlformats.org/drawingml/2006/main">
-          <a:srgbClr val="F7F3EB"/>
-        </a:solidFill>
-      </p:bgPr>
-    </p:bg>
-    <p:spTree>
-      <p:nvGrpSpPr>
-        <p:cNvPr id="1" name=""/>
-        <p:cNvGrpSpPr/>
-        <p:nvPr/>
-      </p:nvGrpSpPr>
-      <p:grpSpPr>
-        <a:xfrm xmlns:a="http://schemas.openxmlformats.org/drawingml/2006/main"/>
-      </p:grpSpPr>
-      <p:sp>
-        <p:nvSpPr>
-          <p:cNvPr id="14" name="section">
-            <a:extLst xmlns:a="http://schemas.openxmlformats.org/drawingml/2006/main">
-              <a:ext uri="{FF2B5EF4-FFF2-40B4-BE49-F238E27FC236}">
-                <a16:creationId xmlns:a16="http://schemas.microsoft.com/office/drawing/2014/main" id="{26283D3D-A815-4079-9718-D29E819DA026}"/>
-              </a:ext>
-            </a:extLst>
-          </p:cNvPr>
-          <p:cNvSpPr>
-            <a:spLocks xmlns:a="http://schemas.openxmlformats.org/drawingml/2006/main" noGrp="1"/>
-          </p:cNvSpPr>
-          <p:nvPr/>
-        </p:nvSpPr>
-        <p:spPr>
-          <a:xfrm xmlns:a="http://schemas.openxmlformats.org/drawingml/2006/main">
-            <a:off x="552450" y="342900"/>
-            <a:ext cx="7429500" cy="238125"/>
-          </a:xfrm>
-          <a:prstGeom xmlns:a="http://schemas.openxmlformats.org/drawingml/2006/main" prst="rect">
-            <a:avLst/>
-          </a:prstGeom>
-          <a:noFill xmlns:a="http://schemas.openxmlformats.org/drawingml/2006/main"/>
-          <a:ln xmlns:a="http://schemas.openxmlformats.org/drawingml/2006/main" w="0">
-            <a:noFill/>
-            <a:prstDash val="solid"/>
-          </a:ln>
-        </p:spPr>
-        <p:txBody>
-          <a:bodyPr xmlns:a="http://schemas.openxmlformats.org/drawingml/2006/main" wrap="square" lIns="0" tIns="0" rIns="0" bIns="0" anchor="t">
-            <a:noAutofit/>
-          </a:bodyPr>
-          <a:lstStyle xmlns:a="http://schemas.openxmlformats.org/drawingml/2006/main"/>
-          <a:p xmlns:a="http://schemas.openxmlformats.org/drawingml/2006/main">
-            <a:pPr algn="l">
-              <a:defRPr sz="1050" b="1">
-                <a:solidFill>
-                  <a:srgbClr val="676A69"/>
-                </a:solidFill>
-                <a:latin typeface="Arial"/>
-                <a:ea typeface="Arial"/>
-                <a:cs typeface="Arial"/>
-              </a:defRPr>
-            </a:pPr>
-            <a:r>
-              <a:rPr sz="1050" b="1">
-                <a:solidFill>
-                  <a:srgbClr val="676A69"/>
-                </a:solidFill>
-                <a:latin typeface="Arial"/>
-                <a:ea typeface="Arial"/>
-                <a:cs typeface="Arial"/>
-              </a:rPr>
-              <a:t>06 / ДЕМО И СЛЕДУЮЩИЕ ШАГИ</a:t>
-            </a:r>
-          </a:p>
-        </p:txBody>
-      </p:sp>
-      <p:sp>
-        <p:nvSpPr>
-          <p:cNvPr id="2" name="title">
-            <a:extLst xmlns:a="http://schemas.openxmlformats.org/drawingml/2006/main">
-              <a:ext uri="{FF2B5EF4-FFF2-40B4-BE49-F238E27FC236}">
-                <a16:creationId xmlns:a16="http://schemas.microsoft.com/office/drawing/2014/main" id="{A805B756-956F-430C-8070-16ABFC5A1B74}"/>
-              </a:ext>
-            </a:extLst>
-          </p:cNvPr>
-          <p:cNvSpPr>
-            <a:spLocks xmlns:a="http://schemas.openxmlformats.org/drawingml/2006/main" noGrp="1"/>
-          </p:cNvSpPr>
-          <p:nvPr/>
-        </p:nvSpPr>
-        <p:spPr>
-          <a:xfrm xmlns:a="http://schemas.openxmlformats.org/drawingml/2006/main">
-            <a:off x="552450" y="695325"/>
-            <a:ext cx="7953375" cy="619125"/>
-          </a:xfrm>
-          <a:prstGeom xmlns:a="http://schemas.openxmlformats.org/drawingml/2006/main" prst="rect">
-            <a:avLst/>
-          </a:prstGeom>
-          <a:noFill xmlns:a="http://schemas.openxmlformats.org/drawingml/2006/main"/>
-          <a:ln xmlns:a="http://schemas.openxmlformats.org/drawingml/2006/main" w="0">
-            <a:noFill/>
-            <a:prstDash val="solid"/>
-          </a:ln>
-        </p:spPr>
-        <p:txBody>
-          <a:bodyPr xmlns:a="http://schemas.openxmlformats.org/drawingml/2006/main" wrap="square" lIns="0" tIns="0" rIns="0" bIns="0" anchor="t">
-            <a:noAutofit/>
-          </a:bodyPr>
-          <a:lstStyle xmlns:a="http://schemas.openxmlformats.org/drawingml/2006/main"/>
-          <a:p xmlns:a="http://schemas.openxmlformats.org/drawingml/2006/main">
-            <a:pPr algn="l">
-              <a:defRPr sz="2550" b="1">
-                <a:solidFill>
-                  <a:srgbClr val="202326"/>
-                </a:solidFill>
-                <a:latin typeface="Arial"/>
-                <a:ea typeface="Arial"/>
-                <a:cs typeface="Arial"/>
-              </a:defRPr>
-            </a:pPr>
-            <a:r>
-              <a:rPr sz="2550" b="1">
-                <a:solidFill>
-                  <a:srgbClr val="202326"/>
-                </a:solidFill>
-                <a:latin typeface="Arial"/>
-                <a:ea typeface="Arial"/>
-                <a:cs typeface="Arial"/>
-              </a:rPr>
-              <a:t>Демо → независимая проверка</a:t>
-            </a:r>
-          </a:p>
-        </p:txBody>
-      </p:sp>
-      <p:sp>
-        <p:nvSpPr>
-          <p:cNvPr id="3" name="top-rule">
-            <a:extLst xmlns:a="http://schemas.openxmlformats.org/drawingml/2006/main">
-              <a:ext uri="{FF2B5EF4-FFF2-40B4-BE49-F238E27FC236}">
-                <a16:creationId xmlns:a16="http://schemas.microsoft.com/office/drawing/2014/main" id="{2B20F414-78E9-4890-BA08-3FEC0C6027DD}"/>
-              </a:ext>
-            </a:extLst>
-          </p:cNvPr>
-          <p:cNvSpPr>
-            <a:spLocks xmlns:a="http://schemas.openxmlformats.org/drawingml/2006/main" noGrp="1"/>
-          </p:cNvSpPr>
-          <p:nvPr/>
-        </p:nvSpPr>
-        <p:spPr>
-          <a:xfrm xmlns:a="http://schemas.openxmlformats.org/drawingml/2006/main">
-            <a:off x="552450" y="1390650"/>
-            <a:ext cx="8039100" cy="9525"/>
-          </a:xfrm>
-          <a:prstGeom xmlns:a="http://schemas.openxmlformats.org/drawingml/2006/main" prst="rect">
-            <a:avLst/>
-          </a:prstGeom>
-          <a:solidFill xmlns:a="http://schemas.openxmlformats.org/drawingml/2006/main">
-            <a:srgbClr val="C9C7C0"/>
-          </a:solidFill>
-          <a:ln xmlns:a="http://schemas.openxmlformats.org/drawingml/2006/main" w="0">
-            <a:noFill/>
-            <a:prstDash val="solid"/>
-          </a:ln>
-        </p:spPr>
-      </p:sp>
-      <p:sp>
-        <p:nvSpPr>
-          <p:cNvPr id="4" name="live-label">
-            <a:extLst xmlns:a="http://schemas.openxmlformats.org/drawingml/2006/main">
-              <a:ext uri="{FF2B5EF4-FFF2-40B4-BE49-F238E27FC236}">
-                <a16:creationId xmlns:a16="http://schemas.microsoft.com/office/drawing/2014/main" id="{445F8A7B-1920-4165-9D33-EA1D7DC709AF}"/>
-              </a:ext>
-            </a:extLst>
-          </p:cNvPr>
-          <p:cNvSpPr>
-            <a:spLocks xmlns:a="http://schemas.openxmlformats.org/drawingml/2006/main" noGrp="1"/>
-          </p:cNvSpPr>
-          <p:nvPr/>
-        </p:nvSpPr>
-        <p:spPr>
-          <a:xfrm xmlns:a="http://schemas.openxmlformats.org/drawingml/2006/main">
-            <a:off x="552450" y="1790700"/>
-            <a:ext cx="4019550" cy="371475"/>
-          </a:xfrm>
-          <a:prstGeom xmlns:a="http://schemas.openxmlformats.org/drawingml/2006/main" prst="rect">
-            <a:avLst/>
-          </a:prstGeom>
-          <a:noFill xmlns:a="http://schemas.openxmlformats.org/drawingml/2006/main"/>
-          <a:ln xmlns:a="http://schemas.openxmlformats.org/drawingml/2006/main" w="0">
-            <a:noFill/>
-            <a:prstDash val="solid"/>
-          </a:ln>
-        </p:spPr>
-        <p:txBody>
-          <a:bodyPr xmlns:a="http://schemas.openxmlformats.org/drawingml/2006/main" wrap="square" lIns="0" tIns="0" rIns="0" bIns="0" anchor="t">
-            <a:noAutofit/>
-          </a:bodyPr>
-          <a:lstStyle xmlns:a="http://schemas.openxmlformats.org/drawingml/2006/main"/>
-          <a:p xmlns:a="http://schemas.openxmlformats.org/drawingml/2006/main">
-            <a:pPr algn="l">
-              <a:defRPr sz="1875" b="1">
-                <a:solidFill>
-                  <a:srgbClr val="C83631"/>
-                </a:solidFill>
-                <a:latin typeface="Arial"/>
-                <a:ea typeface="Arial"/>
-                <a:cs typeface="Arial"/>
-              </a:defRPr>
-            </a:pPr>
-            <a:r>
-              <a:rPr sz="1875" b="1">
-                <a:solidFill>
-                  <a:srgbClr val="C83631"/>
-                </a:solidFill>
-                <a:latin typeface="Arial"/>
-                <a:ea typeface="Arial"/>
-                <a:cs typeface="Arial"/>
-              </a:rPr>
-              <a:t>Сейчас / живое демо</a:t>
-            </a:r>
-          </a:p>
-        </p:txBody>
-      </p:sp>
-      <p:sp>
-        <p:nvSpPr>
-          <p:cNvPr id="5" name="demo-1">
-            <a:extLst xmlns:a="http://schemas.openxmlformats.org/drawingml/2006/main">
-              <a:ext uri="{FF2B5EF4-FFF2-40B4-BE49-F238E27FC236}">
-                <a16:creationId xmlns:a16="http://schemas.microsoft.com/office/drawing/2014/main" id="{7FA7A18F-13CA-4AE5-BC90-669BFC82D22C}"/>
-              </a:ext>
-            </a:extLst>
-          </p:cNvPr>
-          <p:cNvSpPr>
-            <a:spLocks xmlns:a="http://schemas.openxmlformats.org/drawingml/2006/main" noGrp="1"/>
-          </p:cNvSpPr>
-          <p:nvPr/>
-        </p:nvSpPr>
-        <p:spPr>
-          <a:xfrm xmlns:a="http://schemas.openxmlformats.org/drawingml/2006/main">
-            <a:off x="552450" y="2276475"/>
-            <a:ext cx="3886200" cy="409575"/>
-          </a:xfrm>
-          <a:prstGeom xmlns:a="http://schemas.openxmlformats.org/drawingml/2006/main" prst="rect">
-            <a:avLst/>
-          </a:prstGeom>
-          <a:noFill xmlns:a="http://schemas.openxmlformats.org/drawingml/2006/main"/>
-          <a:ln xmlns:a="http://schemas.openxmlformats.org/drawingml/2006/main" w="0">
-            <a:noFill/>
-            <a:prstDash val="solid"/>
-          </a:ln>
-        </p:spPr>
-        <p:txBody>
-          <a:bodyPr xmlns:a="http://schemas.openxmlformats.org/drawingml/2006/main" wrap="square" lIns="0" tIns="0" rIns="0" bIns="0" anchor="t">
-            <a:noAutofit/>
-          </a:bodyPr>
-          <a:lstStyle xmlns:a="http://schemas.openxmlformats.org/drawingml/2006/main"/>
-          <a:p xmlns:a="http://schemas.openxmlformats.org/drawingml/2006/main">
-            <a:pPr algn="l">
-              <a:defRPr sz="1500" b="0">
-                <a:solidFill>
-                  <a:srgbClr val="202326"/>
-                </a:solidFill>
-                <a:latin typeface="Consolas"/>
-                <a:ea typeface="Consolas"/>
-                <a:cs typeface="Consolas"/>
-              </a:defRPr>
-            </a:pPr>
-            <a:r>
-              <a:rPr sz="1500" b="0">
-                <a:solidFill>
-                  <a:srgbClr val="202326"/>
-                </a:solidFill>
-                <a:latin typeface="Consolas"/>
-                <a:ea typeface="Consolas"/>
-                <a:cs typeface="Consolas"/>
-              </a:rPr>
-              <a:t>POST /process</a:t>
-            </a:r>
-          </a:p>
-        </p:txBody>
-      </p:sp>
-      <p:sp>
-        <p:nvSpPr>
-          <p:cNvPr id="6" name="demo-2">
-            <a:extLst xmlns:a="http://schemas.openxmlformats.org/drawingml/2006/main">
-              <a:ext uri="{FF2B5EF4-FFF2-40B4-BE49-F238E27FC236}">
-                <a16:creationId xmlns:a16="http://schemas.microsoft.com/office/drawing/2014/main" id="{25801E9F-BA7E-4538-B129-902F2849575C}"/>
-              </a:ext>
-            </a:extLst>
-          </p:cNvPr>
-          <p:cNvSpPr>
-            <a:spLocks xmlns:a="http://schemas.openxmlformats.org/drawingml/2006/main" noGrp="1"/>
-          </p:cNvSpPr>
-          <p:nvPr/>
-        </p:nvSpPr>
-        <p:spPr>
-          <a:xfrm xmlns:a="http://schemas.openxmlformats.org/drawingml/2006/main">
-            <a:off x="552450" y="2724150"/>
-            <a:ext cx="3886200" cy="885825"/>
-          </a:xfrm>
-          <a:prstGeom xmlns:a="http://schemas.openxmlformats.org/drawingml/2006/main" prst="rect">
-            <a:avLst/>
-          </a:prstGeom>
-          <a:noFill xmlns:a="http://schemas.openxmlformats.org/drawingml/2006/main"/>
-          <a:ln xmlns:a="http://schemas.openxmlformats.org/drawingml/2006/main" w="0">
-            <a:noFill/>
-            <a:prstDash val="solid"/>
-          </a:ln>
-        </p:spPr>
-        <p:txBody>
-          <a:bodyPr xmlns:a="http://schemas.openxmlformats.org/drawingml/2006/main" wrap="square" lIns="0" tIns="0" rIns="0" bIns="0" anchor="t">
-            <a:noAutofit/>
-          </a:bodyPr>
-          <a:lstStyle xmlns:a="http://schemas.openxmlformats.org/drawingml/2006/main"/>
-          <a:p xmlns:a="http://schemas.openxmlformats.org/drawingml/2006/main">
-            <a:pPr algn="l">
-              <a:defRPr sz="1575" b="0">
-                <a:solidFill>
-                  <a:srgbClr val="202326"/>
-                </a:solidFill>
-                <a:latin typeface="Arial"/>
-                <a:ea typeface="Arial"/>
-                <a:cs typeface="Arial"/>
-              </a:defRPr>
-            </a:pPr>
-            <a:r>
-              <a:rPr sz="1575" b="0">
-                <a:solidFill>
-                  <a:srgbClr val="202326"/>
-                </a:solidFill>
-                <a:latin typeface="Arial"/>
-                <a:ea typeface="Arial"/>
-                <a:cs typeface="Arial"/>
-              </a:rPr>
-              <a:t>Синтетический текст → маска →</a:t>
-            </a:r>
-          </a:p>
-          <a:p xmlns:a="http://schemas.openxmlformats.org/drawingml/2006/main">
-            <a:pPr algn="l">
-              <a:defRPr sz="1575" b="0">
-                <a:solidFill>
-                  <a:srgbClr val="202326"/>
-                </a:solidFill>
-                <a:latin typeface="Arial"/>
-                <a:ea typeface="Arial"/>
-                <a:cs typeface="Arial"/>
-              </a:defRPr>
-            </a:pPr>
-            <a:r>
-              <a:rPr sz="1575" b="0">
-                <a:solidFill>
-                  <a:srgbClr val="202326"/>
-                </a:solidFill>
-                <a:latin typeface="Arial"/>
-                <a:ea typeface="Arial"/>
-                <a:cs typeface="Arial"/>
-              </a:rPr>
-              <a:t>повтор с тем же ID → точное</a:t>
-            </a:r>
-          </a:p>
-          <a:p xmlns:a="http://schemas.openxmlformats.org/drawingml/2006/main">
-            <a:pPr algn="l">
-              <a:defRPr sz="1575" b="0">
-                <a:solidFill>
-                  <a:srgbClr val="202326"/>
-                </a:solidFill>
-                <a:latin typeface="Arial"/>
-                <a:ea typeface="Arial"/>
-                <a:cs typeface="Arial"/>
-              </a:defRPr>
-            </a:pPr>
-            <a:r>
-              <a:rPr sz="1575" b="0">
-                <a:solidFill>
-                  <a:srgbClr val="202326"/>
-                </a:solidFill>
-                <a:latin typeface="Arial"/>
-                <a:ea typeface="Arial"/>
-                <a:cs typeface="Arial"/>
-              </a:rPr>
-              <a:t>восстановление.</a:t>
-            </a:r>
-          </a:p>
-        </p:txBody>
-      </p:sp>
-      <p:sp>
-        <p:nvSpPr>
-          <p:cNvPr id="7" name="divider">
-            <a:extLst xmlns:a="http://schemas.openxmlformats.org/drawingml/2006/main">
-              <a:ext uri="{FF2B5EF4-FFF2-40B4-BE49-F238E27FC236}">
-                <a16:creationId xmlns:a16="http://schemas.microsoft.com/office/drawing/2014/main" id="{ABB70D82-E710-4C66-A5DD-F113CE6AAA91}"/>
-              </a:ext>
-            </a:extLst>
-          </p:cNvPr>
-          <p:cNvSpPr>
-            <a:spLocks xmlns:a="http://schemas.openxmlformats.org/drawingml/2006/main" noGrp="1"/>
-          </p:cNvSpPr>
-          <p:nvPr/>
-        </p:nvSpPr>
-        <p:spPr>
-          <a:xfrm xmlns:a="http://schemas.openxmlformats.org/drawingml/2006/main">
-            <a:off x="4743450" y="1790700"/>
-            <a:ext cx="9525" cy="2200275"/>
-          </a:xfrm>
-          <a:prstGeom xmlns:a="http://schemas.openxmlformats.org/drawingml/2006/main" prst="rect">
-            <a:avLst/>
-          </a:prstGeom>
-          <a:solidFill xmlns:a="http://schemas.openxmlformats.org/drawingml/2006/main">
-            <a:srgbClr val="C9C7C0"/>
-          </a:solidFill>
-          <a:ln xmlns:a="http://schemas.openxmlformats.org/drawingml/2006/main" w="0">
-            <a:noFill/>
-            <a:prstDash val="solid"/>
-          </a:ln>
-        </p:spPr>
-      </p:sp>
-      <p:sp>
-        <p:nvSpPr>
-          <p:cNvPr id="8" name="next-label">
-            <a:extLst xmlns:a="http://schemas.openxmlformats.org/drawingml/2006/main">
-              <a:ext uri="{FF2B5EF4-FFF2-40B4-BE49-F238E27FC236}">
-                <a16:creationId xmlns:a16="http://schemas.microsoft.com/office/drawing/2014/main" id="{3D3B406B-D47C-437A-B496-FDBD22C517BF}"/>
-              </a:ext>
-            </a:extLst>
-          </p:cNvPr>
-          <p:cNvSpPr>
-            <a:spLocks xmlns:a="http://schemas.openxmlformats.org/drawingml/2006/main" noGrp="1"/>
-          </p:cNvSpPr>
-          <p:nvPr/>
-        </p:nvSpPr>
-        <p:spPr>
-          <a:xfrm xmlns:a="http://schemas.openxmlformats.org/drawingml/2006/main">
-            <a:off x="5095875" y="1790700"/>
-            <a:ext cx="3409950" cy="371475"/>
-          </a:xfrm>
-          <a:prstGeom xmlns:a="http://schemas.openxmlformats.org/drawingml/2006/main" prst="rect">
-            <a:avLst/>
-          </a:prstGeom>
-          <a:noFill xmlns:a="http://schemas.openxmlformats.org/drawingml/2006/main"/>
-          <a:ln xmlns:a="http://schemas.openxmlformats.org/drawingml/2006/main" w="0">
-            <a:noFill/>
-            <a:prstDash val="solid"/>
-          </a:ln>
-        </p:spPr>
-        <p:txBody>
-          <a:bodyPr xmlns:a="http://schemas.openxmlformats.org/drawingml/2006/main" wrap="square" lIns="0" tIns="0" rIns="0" bIns="0" anchor="t">
-            <a:noAutofit/>
-          </a:bodyPr>
-          <a:lstStyle xmlns:a="http://schemas.openxmlformats.org/drawingml/2006/main"/>
-          <a:p xmlns:a="http://schemas.openxmlformats.org/drawingml/2006/main">
-            <a:pPr algn="l">
-              <a:defRPr sz="1875" b="1">
-                <a:solidFill>
-                  <a:srgbClr val="202326"/>
-                </a:solidFill>
-                <a:latin typeface="Arial"/>
-                <a:ea typeface="Arial"/>
-                <a:cs typeface="Arial"/>
-              </a:defRPr>
-            </a:pPr>
-            <a:r>
-              <a:rPr sz="1875" b="1">
-                <a:solidFill>
-                  <a:srgbClr val="202326"/>
-                </a:solidFill>
-                <a:latin typeface="Arial"/>
-                <a:ea typeface="Arial"/>
-                <a:cs typeface="Arial"/>
-              </a:rPr>
-              <a:t>Дальше / release gates</a:t>
-            </a:r>
-          </a:p>
-        </p:txBody>
-      </p:sp>
-      <p:sp>
-        <p:nvSpPr>
-          <p:cNvPr id="9" name="next-1">
-            <a:extLst xmlns:a="http://schemas.openxmlformats.org/drawingml/2006/main">
-              <a:ext uri="{FF2B5EF4-FFF2-40B4-BE49-F238E27FC236}">
-                <a16:creationId xmlns:a16="http://schemas.microsoft.com/office/drawing/2014/main" id="{C3161F8A-E81F-4042-BCA1-9E73373BB0ED}"/>
-              </a:ext>
-            </a:extLst>
-          </p:cNvPr>
-          <p:cNvSpPr>
-            <a:spLocks xmlns:a="http://schemas.openxmlformats.org/drawingml/2006/main" noGrp="1"/>
-          </p:cNvSpPr>
-          <p:nvPr/>
-        </p:nvSpPr>
-        <p:spPr>
-          <a:xfrm xmlns:a="http://schemas.openxmlformats.org/drawingml/2006/main">
-            <a:off x="5095875" y="2324100"/>
-            <a:ext cx="3238500" cy="781050"/>
-          </a:xfrm>
-          <a:prstGeom xmlns:a="http://schemas.openxmlformats.org/drawingml/2006/main" prst="rect">
-            <a:avLst/>
-          </a:prstGeom>
-          <a:noFill xmlns:a="http://schemas.openxmlformats.org/drawingml/2006/main"/>
-          <a:ln xmlns:a="http://schemas.openxmlformats.org/drawingml/2006/main" w="0">
-            <a:noFill/>
-            <a:prstDash val="solid"/>
-          </a:ln>
-        </p:spPr>
-        <p:txBody>
-          <a:bodyPr xmlns:a="http://schemas.openxmlformats.org/drawingml/2006/main" wrap="square" lIns="0" tIns="0" rIns="0" bIns="0" anchor="t">
-            <a:noAutofit/>
-          </a:bodyPr>
-          <a:lstStyle xmlns:a="http://schemas.openxmlformats.org/drawingml/2006/main"/>
-          <a:p xmlns:a="http://schemas.openxmlformats.org/drawingml/2006/main">
-            <a:pPr algn="l">
-              <a:defRPr sz="1575" b="0">
-                <a:solidFill>
-                  <a:srgbClr val="202326"/>
-                </a:solidFill>
-                <a:latin typeface="Arial"/>
-                <a:ea typeface="Arial"/>
-                <a:cs typeface="Arial"/>
-              </a:defRPr>
-            </a:pPr>
-            <a:r>
-              <a:rPr sz="1575" b="0">
-                <a:solidFill>
-                  <a:srgbClr val="202326"/>
-                </a:solidFill>
-                <a:latin typeface="Arial"/>
-                <a:ea typeface="Arial"/>
-                <a:cs typeface="Arial"/>
-              </a:rPr>
-              <a:t>Ручной независимый holdout</a:t>
-            </a:r>
-          </a:p>
-          <a:p xmlns:a="http://schemas.openxmlformats.org/drawingml/2006/main">
-            <a:pPr algn="l">
-              <a:defRPr sz="1575" b="0">
-                <a:solidFill>
-                  <a:srgbClr val="202326"/>
-                </a:solidFill>
-                <a:latin typeface="Arial"/>
-                <a:ea typeface="Arial"/>
-                <a:cs typeface="Arial"/>
-              </a:defRPr>
-            </a:pPr>
-            <a:r>
-              <a:rPr sz="1575" b="0">
-                <a:solidFill>
-                  <a:srgbClr val="202326"/>
-                </a:solidFill>
-                <a:latin typeface="Arial"/>
-                <a:ea typeface="Arial"/>
-                <a:cs typeface="Arial"/>
-              </a:rPr>
-              <a:t>от 170 примеров.</a:t>
-            </a:r>
-          </a:p>
-        </p:txBody>
-      </p:sp>
-      <p:sp>
-        <p:nvSpPr>
-          <p:cNvPr id="10" name="next-2">
-            <a:extLst xmlns:a="http://schemas.openxmlformats.org/drawingml/2006/main">
-              <a:ext uri="{FF2B5EF4-FFF2-40B4-BE49-F238E27FC236}">
-                <a16:creationId xmlns:a16="http://schemas.microsoft.com/office/drawing/2014/main" id="{1BC29B25-4BAF-4345-A82C-8D00D6BF242C}"/>
-              </a:ext>
-            </a:extLst>
-          </p:cNvPr>
-          <p:cNvSpPr>
-            <a:spLocks xmlns:a="http://schemas.openxmlformats.org/drawingml/2006/main" noGrp="1"/>
-          </p:cNvSpPr>
-          <p:nvPr/>
-        </p:nvSpPr>
-        <p:spPr>
-          <a:xfrm xmlns:a="http://schemas.openxmlformats.org/drawingml/2006/main">
-            <a:off x="5095875" y="3162300"/>
-            <a:ext cx="3352800" cy="809625"/>
-          </a:xfrm>
-          <a:prstGeom xmlns:a="http://schemas.openxmlformats.org/drawingml/2006/main" prst="rect">
-            <a:avLst/>
-          </a:prstGeom>
-          <a:noFill xmlns:a="http://schemas.openxmlformats.org/drawingml/2006/main"/>
-          <a:ln xmlns:a="http://schemas.openxmlformats.org/drawingml/2006/main" w="0">
-            <a:noFill/>
-            <a:prstDash val="solid"/>
-          </a:ln>
-        </p:spPr>
-        <p:txBody>
-          <a:bodyPr xmlns:a="http://schemas.openxmlformats.org/drawingml/2006/main" wrap="square" lIns="0" tIns="0" rIns="0" bIns="0" anchor="t">
-            <a:noAutofit/>
-          </a:bodyPr>
-          <a:lstStyle xmlns:a="http://schemas.openxmlformats.org/drawingml/2006/main"/>
-          <a:p xmlns:a="http://schemas.openxmlformats.org/drawingml/2006/main">
-            <a:pPr algn="l">
-              <a:defRPr sz="1575" b="0">
-                <a:solidFill>
-                  <a:srgbClr val="202326"/>
-                </a:solidFill>
-                <a:latin typeface="Arial"/>
-                <a:ea typeface="Arial"/>
-                <a:cs typeface="Arial"/>
-              </a:defRPr>
-            </a:pPr>
-            <a:r>
-              <a:rPr sz="1575" b="0">
-                <a:solidFill>
-                  <a:srgbClr val="202326"/>
-                </a:solidFill>
-                <a:latin typeface="Arial"/>
-                <a:ea typeface="Arial"/>
-                <a:cs typeface="Arial"/>
-              </a:rPr>
-              <a:t>Нагрузка на конечном</a:t>
-            </a:r>
-          </a:p>
-          <a:p xmlns:a="http://schemas.openxmlformats.org/drawingml/2006/main">
-            <a:pPr algn="l">
-              <a:defRPr sz="1575" b="0">
-                <a:solidFill>
-                  <a:srgbClr val="202326"/>
-                </a:solidFill>
-                <a:latin typeface="Arial"/>
-                <a:ea typeface="Arial"/>
-                <a:cs typeface="Arial"/>
-              </a:defRPr>
-            </a:pPr>
-            <a:r>
-              <a:rPr sz="1575" b="0">
-                <a:solidFill>
-                  <a:srgbClr val="202326"/>
-                </a:solidFill>
-                <a:latin typeface="Arial"/>
-                <a:ea typeface="Arial"/>
-                <a:cs typeface="Arial"/>
-              </a:rPr>
-              <a:t>развёртывании с отдельным</a:t>
-            </a:r>
-          </a:p>
-          <a:p xmlns:a="http://schemas.openxmlformats.org/drawingml/2006/main">
-            <a:pPr algn="l">
-              <a:defRPr sz="1575" b="0">
-                <a:solidFill>
-                  <a:srgbClr val="202326"/>
-                </a:solidFill>
-                <a:latin typeface="Arial"/>
-                <a:ea typeface="Arial"/>
-                <a:cs typeface="Arial"/>
-              </a:defRPr>
-            </a:pPr>
-            <a:r>
-              <a:rPr sz="1575" b="0">
-                <a:solidFill>
-                  <a:srgbClr val="202326"/>
-                </a:solidFill>
-                <a:latin typeface="Arial"/>
-                <a:ea typeface="Arial"/>
-                <a:cs typeface="Arial"/>
-              </a:rPr>
-              <a:t>генератором.</a:t>
-            </a:r>
-          </a:p>
-        </p:txBody>
-      </p:sp>
-      <p:sp>
-        <p:nvSpPr>
-          <p:cNvPr id="11" name="bottom-rule">
-            <a:extLst xmlns:a="http://schemas.openxmlformats.org/drawingml/2006/main">
-              <a:ext uri="{FF2B5EF4-FFF2-40B4-BE49-F238E27FC236}">
-                <a16:creationId xmlns:a16="http://schemas.microsoft.com/office/drawing/2014/main" id="{D56068BD-11F3-43FB-9B8E-5C36D514266D}"/>
-              </a:ext>
-            </a:extLst>
-          </p:cNvPr>
-          <p:cNvSpPr>
-            <a:spLocks xmlns:a="http://schemas.openxmlformats.org/drawingml/2006/main" noGrp="1"/>
-          </p:cNvSpPr>
-          <p:nvPr/>
-        </p:nvSpPr>
-        <p:spPr>
-          <a:xfrm xmlns:a="http://schemas.openxmlformats.org/drawingml/2006/main">
-            <a:off x="552450" y="4391025"/>
-            <a:ext cx="8039100" cy="9525"/>
-          </a:xfrm>
-          <a:prstGeom xmlns:a="http://schemas.openxmlformats.org/drawingml/2006/main" prst="rect">
-            <a:avLst/>
-          </a:prstGeom>
-          <a:solidFill xmlns:a="http://schemas.openxmlformats.org/drawingml/2006/main">
-            <a:srgbClr val="C83631"/>
-          </a:solidFill>
-          <a:ln xmlns:a="http://schemas.openxmlformats.org/drawingml/2006/main" w="0">
-            <a:noFill/>
-            <a:prstDash val="solid"/>
-          </a:ln>
-        </p:spPr>
-      </p:sp>
-      <p:sp>
-        <p:nvSpPr>
-          <p:cNvPr id="12" name="footer">
-            <a:extLst xmlns:a="http://schemas.openxmlformats.org/drawingml/2006/main">
-              <a:ext uri="{FF2B5EF4-FFF2-40B4-BE49-F238E27FC236}">
-                <a16:creationId xmlns:a16="http://schemas.microsoft.com/office/drawing/2014/main" id="{6CFE3228-7EA6-4741-A9A9-438CC0AAEFE3}"/>
-              </a:ext>
-            </a:extLst>
-          </p:cNvPr>
-          <p:cNvSpPr>
-            <a:spLocks xmlns:a="http://schemas.openxmlformats.org/drawingml/2006/main" noGrp="1"/>
-          </p:cNvSpPr>
-          <p:nvPr/>
-        </p:nvSpPr>
-        <p:spPr>
-          <a:xfrm xmlns:a="http://schemas.openxmlformats.org/drawingml/2006/main">
-            <a:off x="552450" y="4543425"/>
-            <a:ext cx="7096125" cy="276225"/>
-          </a:xfrm>
-          <a:prstGeom xmlns:a="http://schemas.openxmlformats.org/drawingml/2006/main" prst="rect">
-            <a:avLst/>
-          </a:prstGeom>
-          <a:noFill xmlns:a="http://schemas.openxmlformats.org/drawingml/2006/main"/>
-          <a:ln xmlns:a="http://schemas.openxmlformats.org/drawingml/2006/main" w="0">
-            <a:noFill/>
-            <a:prstDash val="solid"/>
-          </a:ln>
-        </p:spPr>
-        <p:txBody>
-          <a:bodyPr xmlns:a="http://schemas.openxmlformats.org/drawingml/2006/main" wrap="square" lIns="0" tIns="0" rIns="0" bIns="0" anchor="t">
-            <a:noAutofit/>
-          </a:bodyPr>
-          <a:lstStyle xmlns:a="http://schemas.openxmlformats.org/drawingml/2006/main"/>
-          <a:p xmlns:a="http://schemas.openxmlformats.org/drawingml/2006/main">
-            <a:pPr algn="l">
-              <a:defRPr sz="1050" b="0">
-                <a:solidFill>
-                  <a:srgbClr val="676A69"/>
-                </a:solidFill>
-                <a:latin typeface="Arial"/>
-                <a:ea typeface="Arial"/>
-                <a:cs typeface="Arial"/>
-              </a:defRPr>
-            </a:pPr>
-            <a:r>
-              <a:rPr sz="1050" b="0">
-                <a:solidFill>
-                  <a:srgbClr val="676A69"/>
-                </a:solidFill>
-                <a:latin typeface="Arial"/>
-                <a:ea typeface="Arial"/>
-                <a:cs typeface="Arial"/>
-              </a:rPr>
-              <a:t>Демо-доступ через Quick Tunnel — не подтверждение доступности или SLA.</a:t>
-            </a:r>
-          </a:p>
-        </p:txBody>
-      </p:sp>
-      <p:sp>
-        <p:nvSpPr>
-          <p:cNvPr id="13" name="page">
-            <a:extLst xmlns:a="http://schemas.openxmlformats.org/drawingml/2006/main">
-              <a:ext uri="{FF2B5EF4-FFF2-40B4-BE49-F238E27FC236}">
-                <a16:creationId xmlns:a16="http://schemas.microsoft.com/office/drawing/2014/main" id="{241A328C-BADF-4082-8AFD-08D5E25CBEAD}"/>
-              </a:ext>
-            </a:extLst>
-          </p:cNvPr>
-          <p:cNvSpPr>
-            <a:spLocks xmlns:a="http://schemas.openxmlformats.org/drawingml/2006/main" noGrp="1"/>
-          </p:cNvSpPr>
-          <p:nvPr/>
-        </p:nvSpPr>
-        <p:spPr>
-          <a:xfrm xmlns:a="http://schemas.openxmlformats.org/drawingml/2006/main">
-            <a:off x="7924800" y="4648200"/>
-            <a:ext cx="666750" cy="190500"/>
-          </a:xfrm>
-          <a:prstGeom xmlns:a="http://schemas.openxmlformats.org/drawingml/2006/main" prst="rect">
-            <a:avLst/>
-          </a:prstGeom>
-          <a:noFill xmlns:a="http://schemas.openxmlformats.org/drawingml/2006/main"/>
-          <a:ln xmlns:a="http://schemas.openxmlformats.org/drawingml/2006/main" w="0">
-            <a:noFill/>
-            <a:prstDash val="solid"/>
-          </a:ln>
-        </p:spPr>
-        <p:txBody>
-          <a:bodyPr xmlns:a="http://schemas.openxmlformats.org/drawingml/2006/main" wrap="square" lIns="0" tIns="0" rIns="0" bIns="0" anchor="t">
-            <a:noAutofit/>
-          </a:bodyPr>
-          <a:lstStyle xmlns:a="http://schemas.openxmlformats.org/drawingml/2006/main"/>
-          <a:p xmlns:a="http://schemas.openxmlformats.org/drawingml/2006/main">
-            <a:pPr algn="r">
-              <a:defRPr sz="1050" b="0">
-                <a:solidFill>
-                  <a:srgbClr val="676A69"/>
-                </a:solidFill>
-                <a:latin typeface="Arial"/>
-                <a:ea typeface="Arial"/>
-                <a:cs typeface="Arial"/>
-              </a:defRPr>
-            </a:pPr>
-            <a:r>
-              <a:rPr sz="1050" b="0">
-                <a:solidFill>
-                  <a:srgbClr val="676A69"/>
-                </a:solidFill>
-                <a:latin typeface="Arial"/>
-                <a:ea typeface="Arial"/>
-                <a:cs typeface="Arial"/>
-              </a:rPr>
-              <a:t>07 / 07</a:t>
-            </a:r>
-          </a:p>
-        </p:txBody>
-      </p:sp>
-    </p:spTree>
-    <p:extLst>
-      <p:ext uri="{BB962C8B-B14F-4D97-AF65-F5344CB8AC3E}">
-        <p14:creationId xmlns:p14="http://schemas.microsoft.com/office/powerpoint/2010/main" val="900741755"/>
+        <p14:creationId xmlns:p14="http://schemas.microsoft.com/office/powerpoint/2010/main" val="804827765"/>
       </p:ext>
     </p:extLst>
   </p:cSld>

</xml_diff>